<commit_message>
Sophisticated deck — batch 2: 3-col stats, feature grid, before/after (slides 4-6)
Three more slides exercising:
  * 3-column stat cards: gradient inner fill, ▲/▼ delta pills with semantic
    color (green/rose), hairline-divided description footer
  * 6-card feature grid: 6 distinct gradient icon containers (indigo→purple,
    purple→pink, pink→orange, cyan→indigo, green→cyan, orange→yellow),
    h3 titles, body copy, uppercase meta tag
  * Before/After comparison: two columns (bad in zinc, good in gradient
    with glow), 5 ✗/✓ rows each, semantic colors

Conversion result on slides 1-6:
  native_area_ratio  : 1.000
  pattern_coverage   : 0.896
  cache_hit_rate     : 0.650 (signature reuse paying off)
  top patterns       : kicker-from-css ×5, body-paragraph ×5,
                       pill-from-css ×5, slide-solid-bg ×5, title-h1 ×4
  unmatched          : 5

https://claude.ai/code/session_01CZur2pybdDENkAGSn3vNWP
</commit_message>
<xml_diff>
--- a/examples/sophisticated/deck.pptx
+++ b/examples/sophisticated/deck.pptx
@@ -8,6 +8,9 @@
     <p:sldId id="256" r:id="rId7"/>
     <p:sldId id="257" r:id="rId8"/>
     <p:sldId id="258" r:id="rId9"/>
+    <p:sldId id="259" r:id="rId10"/>
+    <p:sldId id="260" r:id="rId11"/>
+    <p:sldId id="261" r:id="rId12"/>
   </p:sldIdLst>
   <p:sldSz cx="12192000" cy="6858000" type="screen4x3"/>
   <p:notesSz cx="6858000" cy="9144000"/>
@@ -4979,6 +4982,3538 @@
                 <a:latin typeface="Inter"/>
               </a:rPr>
               <a:t>03 / 12</a:t>
+            </a:r>
+          </a:p>
+        </p:txBody>
+      </p:sp>
+    </p:spTree>
+  </p:cSld>
+  <p:clrMapOvr>
+    <a:masterClrMapping/>
+  </p:clrMapOvr>
+</p:sld>
+</file>
+
+<file path=ppt/slides/slide4.xml><?xml version="1.0" encoding="utf-8"?>
+<p:sld xmlns:a="http://schemas.openxmlformats.org/drawingml/2006/main" xmlns:p="http://schemas.openxmlformats.org/presentationml/2006/main" xmlns:r="http://schemas.openxmlformats.org/officeDocument/2006/relationships">
+  <p:cSld>
+    <p:spTree>
+      <p:nvGrpSpPr>
+        <p:cNvPr id="1" name=""/>
+        <p:cNvGrpSpPr/>
+        <p:nvPr/>
+      </p:nvGrpSpPr>
+      <p:grpSpPr/>
+      <p:sp>
+        <p:nvSpPr>
+          <p:cNvPr id="2" name="Rectangle 1"/>
+          <p:cNvSpPr/>
+          <p:nvPr/>
+        </p:nvSpPr>
+        <p:spPr>
+          <a:xfrm>
+            <a:off x="0" y="0"/>
+            <a:ext cx="12192000" cy="6858000"/>
+          </a:xfrm>
+          <a:prstGeom prst="rect">
+            <a:avLst/>
+          </a:prstGeom>
+          <a:solidFill>
+            <a:srgbClr val="070710"/>
+          </a:solidFill>
+          <a:ln>
+            <a:noFill/>
+          </a:ln>
+        </p:spPr>
+        <p:style>
+          <a:lnRef idx="1">
+            <a:schemeClr val="accent1"/>
+          </a:lnRef>
+          <a:fillRef idx="3">
+            <a:schemeClr val="accent1"/>
+          </a:fillRef>
+          <a:effectRef idx="2">
+            <a:schemeClr val="accent1"/>
+          </a:effectRef>
+          <a:fontRef idx="minor">
+            <a:schemeClr val="lt1"/>
+          </a:fontRef>
+        </p:style>
+        <p:txBody>
+          <a:bodyPr rtlCol="0" anchor="ctr"/>
+          <a:lstStyle/>
+          <a:p>
+            <a:pPr algn="ctr"/>
+          </a:p>
+        </p:txBody>
+      </p:sp>
+      <p:sp>
+        <p:nvSpPr>
+          <p:cNvPr id="3" name="TextBox 2"/>
+          <p:cNvSpPr txBox="1"/>
+          <p:nvPr/>
+        </p:nvSpPr>
+        <p:spPr>
+          <a:xfrm>
+            <a:off x="762000" y="762000"/>
+            <a:ext cx="10668000" cy="152400"/>
+          </a:xfrm>
+          <a:prstGeom prst="rect">
+            <a:avLst/>
+          </a:prstGeom>
+          <a:noFill/>
+        </p:spPr>
+        <p:txBody>
+          <a:bodyPr wrap="square" lIns="0" rIns="0" tIns="0" bIns="0">
+            <a:spAutoFit/>
+          </a:bodyPr>
+          <a:lstStyle/>
+          <a:p>
+            <a:pPr algn="l"/>
+            <a:r>
+              <a:rPr sz="975" b="1" i="0" u="none">
+                <a:solidFill>
+                  <a:srgbClr val="A78BFA"/>
+                </a:solidFill>
+                <a:latin typeface="Inter"/>
+              </a:rPr>
+              <a:t>By the numbers</a:t>
+            </a:r>
+          </a:p>
+        </p:txBody>
+      </p:sp>
+      <p:sp>
+        <p:nvSpPr>
+          <p:cNvPr id="4" name="TextBox 3"/>
+          <p:cNvSpPr txBox="1"/>
+          <p:nvPr/>
+        </p:nvSpPr>
+        <p:spPr>
+          <a:xfrm>
+            <a:off x="762000" y="1085850"/>
+            <a:ext cx="8572500" cy="959941"/>
+          </a:xfrm>
+          <a:prstGeom prst="rect">
+            <a:avLst/>
+          </a:prstGeom>
+          <a:noFill/>
+        </p:spPr>
+        <p:txBody>
+          <a:bodyPr wrap="square" lIns="0" rIns="0" tIns="0" bIns="0">
+            <a:spAutoFit/>
+          </a:bodyPr>
+          <a:lstStyle/>
+          <a:p>
+            <a:pPr algn="l"/>
+            <a:r>
+              <a:rPr sz="3600" b="1" i="0" u="none">
+                <a:solidFill>
+                  <a:srgbClr val="F5F5F7"/>
+                </a:solidFill>
+                <a:latin typeface="Inter"/>
+              </a:rPr>
+              <a:t>Editability that compounds across every deck shipped.</a:t>
+            </a:r>
+          </a:p>
+        </p:txBody>
+      </p:sp>
+      <p:sp>
+        <p:nvSpPr>
+          <p:cNvPr id="5" name="Rounded Rectangle 4"/>
+          <p:cNvSpPr/>
+          <p:nvPr/>
+        </p:nvSpPr>
+        <p:spPr>
+          <a:gradFill flip="none" rotWithShape="1">
+            <a:gsLst>
+              <a:gs pos="0">
+                <a:srgbClr val="FFFFFF">
+                  <a:alpha val="5000"/>
+                </a:srgbClr>
+              </a:gs>
+              <a:gs pos="100000">
+                <a:srgbClr val="FFFFFF">
+                  <a:alpha val="2000"/>
+                </a:srgbClr>
+              </a:gs>
+            </a:gsLst>
+            <a:lin ang="5400000" scaled="0"/>
+          </a:gradFill>
+          <a:xfrm>
+            <a:off x="762000" y="2502991"/>
+            <a:ext cx="3403550" cy="3153370"/>
+          </a:xfrm>
+          <a:prstGeom prst="roundRect">
+            <a:avLst/>
+          </a:prstGeom>
+          <a:ln w="9525">
+            <a:solidFill>
+              <a:srgbClr val="FFFFFF"/>
+            </a:solidFill>
+          </a:ln>
+          <a:effectLst>
+            <a:outerShdw blurRad="571500" dist="228600" dir="5400000" algn="ctr" rotWithShape="0">
+              <a:srgbClr val="6366F1">
+                <a:alpha val="8000"/>
+              </a:srgbClr>
+            </a:outerShdw>
+          </a:effectLst>
+        </p:spPr>
+        <p:style>
+          <a:lnRef idx="1">
+            <a:schemeClr val="accent1"/>
+          </a:lnRef>
+          <a:fillRef idx="3">
+            <a:schemeClr val="accent1"/>
+          </a:fillRef>
+          <a:effectRef idx="2">
+            <a:schemeClr val="accent1"/>
+          </a:effectRef>
+          <a:fontRef idx="minor">
+            <a:schemeClr val="lt1"/>
+          </a:fontRef>
+        </p:style>
+        <p:txBody>
+          <a:bodyPr rtlCol="0" anchor="ctr"/>
+          <a:lstStyle/>
+          <a:p>
+            <a:pPr algn="ctr"/>
+          </a:p>
+        </p:txBody>
+      </p:sp>
+      <p:sp>
+        <p:nvSpPr>
+          <p:cNvPr id="6" name="TextBox 5"/>
+          <p:cNvSpPr txBox="1"/>
+          <p:nvPr/>
+        </p:nvSpPr>
+        <p:spPr>
+          <a:xfrm>
+            <a:off x="1076325" y="2855416"/>
+            <a:ext cx="2774900" cy="152400"/>
+          </a:xfrm>
+          <a:prstGeom prst="rect">
+            <a:avLst/>
+          </a:prstGeom>
+          <a:noFill/>
+        </p:spPr>
+        <p:txBody>
+          <a:bodyPr wrap="square" lIns="0" rIns="0" tIns="0" bIns="0">
+            <a:spAutoFit/>
+          </a:bodyPr>
+          <a:lstStyle/>
+          <a:p>
+            <a:pPr algn="l"/>
+            <a:r>
+              <a:rPr sz="975" b="1" i="0" u="none">
+                <a:solidFill>
+                  <a:srgbClr val="A1A1AA"/>
+                </a:solidFill>
+                <a:latin typeface="Inter"/>
+              </a:rPr>
+              <a:t>Native area</a:t>
+            </a:r>
+          </a:p>
+        </p:txBody>
+      </p:sp>
+      <p:sp>
+        <p:nvSpPr>
+          <p:cNvPr id="7" name="TextBox 6"/>
+          <p:cNvSpPr txBox="1"/>
+          <p:nvPr/>
+        </p:nvSpPr>
+        <p:spPr>
+          <a:xfrm>
+            <a:off x="1076325" y="3141166"/>
+            <a:ext cx="2774900" cy="838200"/>
+          </a:xfrm>
+          <a:prstGeom prst="rect">
+            <a:avLst/>
+          </a:prstGeom>
+          <a:noFill/>
+        </p:spPr>
+        <p:txBody>
+          <a:bodyPr wrap="square" lIns="0" rIns="0" tIns="0" bIns="0">
+            <a:spAutoFit/>
+          </a:bodyPr>
+          <a:lstStyle/>
+          <a:p>
+            <a:pPr algn="l"/>
+            <a:r>
+              <a:rPr sz="6600" b="1" i="0" u="none">
+                <a:solidFill>
+                  <a:srgbClr val="F5F5F7"/>
+                </a:solidFill>
+                <a:latin typeface="Inter"/>
+              </a:rPr>
+              <a:t>87</a:t>
+            </a:r>
+            <a:r>
+              <a:rPr sz="3000" b="1" i="0" u="none">
+                <a:solidFill>
+                  <a:srgbClr val="A78BFA"/>
+                </a:solidFill>
+                <a:latin typeface="Inter"/>
+              </a:rPr>
+              <a:t>%</a:t>
+            </a:r>
+          </a:p>
+        </p:txBody>
+      </p:sp>
+      <p:sp>
+        <p:nvSpPr>
+          <p:cNvPr id="8" name="TextBox 7"/>
+          <p:cNvSpPr txBox="1"/>
+          <p:nvPr/>
+        </p:nvSpPr>
+        <p:spPr>
+          <a:xfrm>
+            <a:off x="1076325" y="4112716"/>
+            <a:ext cx="799207" cy="238125"/>
+          </a:xfrm>
+          <a:prstGeom prst="rect">
+            <a:avLst/>
+          </a:prstGeom>
+          <a:solidFill>
+            <a:srgbClr val="22C55E"/>
+          </a:solidFill>
+        </p:spPr>
+        <p:txBody>
+          <a:bodyPr wrap="square" lIns="0" rIns="0" tIns="0" bIns="0">
+            <a:spAutoFit/>
+          </a:bodyPr>
+          <a:lstStyle/>
+          <a:p>
+            <a:pPr algn="l"/>
+            <a:r>
+              <a:rPr sz="900" b="1" i="0" u="none">
+                <a:solidFill>
+                  <a:srgbClr val="86EFAC"/>
+                </a:solidFill>
+                <a:latin typeface="Inter"/>
+              </a:rPr>
+              <a:t>▲ +29.4%</a:t>
+            </a:r>
+          </a:p>
+        </p:txBody>
+      </p:sp>
+      <p:sp>
+        <p:nvSpPr>
+          <p:cNvPr id="9" name="TextBox 8"/>
+          <p:cNvSpPr txBox="1"/>
+          <p:nvPr/>
+        </p:nvSpPr>
+        <p:spPr>
+          <a:xfrm>
+            <a:off x="1951732" y="4160341"/>
+            <a:ext cx="774650" cy="142875"/>
+          </a:xfrm>
+          <a:prstGeom prst="rect">
+            <a:avLst/>
+          </a:prstGeom>
+          <a:noFill/>
+        </p:spPr>
+        <p:txBody>
+          <a:bodyPr wrap="square" lIns="0" rIns="0" tIns="0" bIns="0">
+            <a:spAutoFit/>
+          </a:bodyPr>
+          <a:lstStyle/>
+          <a:p>
+            <a:pPr algn="l"/>
+            <a:r>
+              <a:rPr sz="900" b="0" i="0" u="none">
+                <a:solidFill>
+                  <a:srgbClr val="52525B"/>
+                </a:solidFill>
+                <a:latin typeface="Inter"/>
+              </a:rPr>
+              <a:t>vs Q1 baseline</a:t>
+            </a:r>
+          </a:p>
+        </p:txBody>
+      </p:sp>
+      <p:sp>
+        <p:nvSpPr>
+          <p:cNvPr id="10" name="TextBox 9"/>
+          <p:cNvSpPr txBox="1"/>
+          <p:nvPr/>
+        </p:nvSpPr>
+        <p:spPr>
+          <a:xfrm>
+            <a:off x="1076325" y="4522291"/>
+            <a:ext cx="2774900" cy="781645"/>
+          </a:xfrm>
+          <a:prstGeom prst="rect">
+            <a:avLst/>
+          </a:prstGeom>
+          <a:noFill/>
+        </p:spPr>
+        <p:txBody>
+          <a:bodyPr wrap="square" lIns="0" rIns="0" tIns="0" bIns="0">
+            <a:spAutoFit/>
+          </a:bodyPr>
+          <a:lstStyle/>
+          <a:p>
+            <a:pPr algn="l"/>
+            <a:r>
+              <a:rPr sz="1050" b="0" i="0" u="none">
+                <a:solidFill>
+                  <a:srgbClr val="A1A1AA"/>
+                </a:solidFill>
+                <a:latin typeface="Inter"/>
+              </a:rPr>
+              <a:t>Average across the corpus. Tier-0 patterns landed in March; Q2 added composite recipes for stat- and feature-cards.</a:t>
+            </a:r>
+          </a:p>
+        </p:txBody>
+      </p:sp>
+      <p:sp>
+        <p:nvSpPr>
+          <p:cNvPr id="11" name="Rounded Rectangle 10"/>
+          <p:cNvSpPr/>
+          <p:nvPr/>
+        </p:nvSpPr>
+        <p:spPr>
+          <a:gradFill flip="none" rotWithShape="1">
+            <a:gsLst>
+              <a:gs pos="0">
+                <a:srgbClr val="FFFFFF">
+                  <a:alpha val="5000"/>
+                </a:srgbClr>
+              </a:gs>
+              <a:gs pos="100000">
+                <a:srgbClr val="FFFFFF">
+                  <a:alpha val="2000"/>
+                </a:srgbClr>
+              </a:gs>
+            </a:gsLst>
+            <a:lin ang="5400000" scaled="0"/>
+          </a:gradFill>
+          <a:xfrm>
+            <a:off x="4394150" y="2502991"/>
+            <a:ext cx="3403550" cy="3153370"/>
+          </a:xfrm>
+          <a:prstGeom prst="roundRect">
+            <a:avLst/>
+          </a:prstGeom>
+          <a:ln w="9525">
+            <a:solidFill>
+              <a:srgbClr val="FFFFFF"/>
+            </a:solidFill>
+          </a:ln>
+          <a:effectLst>
+            <a:outerShdw blurRad="571500" dist="228600" dir="5400000" algn="ctr" rotWithShape="0">
+              <a:srgbClr val="6366F1">
+                <a:alpha val="8000"/>
+              </a:srgbClr>
+            </a:outerShdw>
+          </a:effectLst>
+        </p:spPr>
+        <p:style>
+          <a:lnRef idx="1">
+            <a:schemeClr val="accent1"/>
+          </a:lnRef>
+          <a:fillRef idx="3">
+            <a:schemeClr val="accent1"/>
+          </a:fillRef>
+          <a:effectRef idx="2">
+            <a:schemeClr val="accent1"/>
+          </a:effectRef>
+          <a:fontRef idx="minor">
+            <a:schemeClr val="lt1"/>
+          </a:fontRef>
+        </p:style>
+        <p:txBody>
+          <a:bodyPr rtlCol="0" anchor="ctr"/>
+          <a:lstStyle/>
+          <a:p>
+            <a:pPr algn="ctr"/>
+          </a:p>
+        </p:txBody>
+      </p:sp>
+      <p:sp>
+        <p:nvSpPr>
+          <p:cNvPr id="12" name="TextBox 11"/>
+          <p:cNvSpPr txBox="1"/>
+          <p:nvPr/>
+        </p:nvSpPr>
+        <p:spPr>
+          <a:xfrm>
+            <a:off x="4708475" y="2855416"/>
+            <a:ext cx="2774900" cy="152400"/>
+          </a:xfrm>
+          <a:prstGeom prst="rect">
+            <a:avLst/>
+          </a:prstGeom>
+          <a:noFill/>
+        </p:spPr>
+        <p:txBody>
+          <a:bodyPr wrap="square" lIns="0" rIns="0" tIns="0" bIns="0">
+            <a:spAutoFit/>
+          </a:bodyPr>
+          <a:lstStyle/>
+          <a:p>
+            <a:pPr algn="l"/>
+            <a:r>
+              <a:rPr sz="975" b="1" i="0" u="none">
+                <a:solidFill>
+                  <a:srgbClr val="A1A1AA"/>
+                </a:solidFill>
+                <a:latin typeface="Inter"/>
+              </a:rPr>
+              <a:t>Per 10-slide deck</a:t>
+            </a:r>
+          </a:p>
+        </p:txBody>
+      </p:sp>
+      <p:sp>
+        <p:nvSpPr>
+          <p:cNvPr id="13" name="TextBox 12"/>
+          <p:cNvSpPr txBox="1"/>
+          <p:nvPr/>
+        </p:nvSpPr>
+        <p:spPr>
+          <a:xfrm>
+            <a:off x="4708475" y="3141166"/>
+            <a:ext cx="2774900" cy="838200"/>
+          </a:xfrm>
+          <a:prstGeom prst="rect">
+            <a:avLst/>
+          </a:prstGeom>
+          <a:noFill/>
+        </p:spPr>
+        <p:txBody>
+          <a:bodyPr wrap="square" lIns="0" rIns="0" tIns="0" bIns="0">
+            <a:spAutoFit/>
+          </a:bodyPr>
+          <a:lstStyle/>
+          <a:p>
+            <a:pPr algn="l"/>
+            <a:r>
+              <a:rPr sz="6600" b="1" i="0" u="none">
+                <a:solidFill>
+                  <a:srgbClr val="F5F5F7"/>
+                </a:solidFill>
+                <a:latin typeface="Inter"/>
+              </a:rPr>
+              <a:t>23</a:t>
+            </a:r>
+            <a:r>
+              <a:rPr sz="3000" b="1" i="0" u="none">
+                <a:solidFill>
+                  <a:srgbClr val="A78BFA"/>
+                </a:solidFill>
+                <a:latin typeface="Inter"/>
+              </a:rPr>
+              <a:t>s</a:t>
+            </a:r>
+          </a:p>
+        </p:txBody>
+      </p:sp>
+      <p:sp>
+        <p:nvSpPr>
+          <p:cNvPr id="14" name="TextBox 13"/>
+          <p:cNvSpPr txBox="1"/>
+          <p:nvPr/>
+        </p:nvSpPr>
+        <p:spPr>
+          <a:xfrm>
+            <a:off x="4708475" y="4112716"/>
+            <a:ext cx="645468" cy="238125"/>
+          </a:xfrm>
+          <a:prstGeom prst="rect">
+            <a:avLst/>
+          </a:prstGeom>
+          <a:solidFill>
+            <a:srgbClr val="F43F5E"/>
+          </a:solidFill>
+        </p:spPr>
+        <p:txBody>
+          <a:bodyPr wrap="square" lIns="0" rIns="0" tIns="0" bIns="0">
+            <a:spAutoFit/>
+          </a:bodyPr>
+          <a:lstStyle/>
+          <a:p>
+            <a:pPr algn="l"/>
+            <a:r>
+              <a:rPr sz="900" b="1" i="0" u="none">
+                <a:solidFill>
+                  <a:srgbClr val="FDA4AF"/>
+                </a:solidFill>
+                <a:latin typeface="Inter"/>
+              </a:rPr>
+              <a:t>▼ -41%</a:t>
+            </a:r>
+          </a:p>
+        </p:txBody>
+      </p:sp>
+      <p:sp>
+        <p:nvSpPr>
+          <p:cNvPr id="15" name="TextBox 14"/>
+          <p:cNvSpPr txBox="1"/>
+          <p:nvPr/>
+        </p:nvSpPr>
+        <p:spPr>
+          <a:xfrm>
+            <a:off x="5430143" y="4160341"/>
+            <a:ext cx="774650" cy="142875"/>
+          </a:xfrm>
+          <a:prstGeom prst="rect">
+            <a:avLst/>
+          </a:prstGeom>
+          <a:noFill/>
+        </p:spPr>
+        <p:txBody>
+          <a:bodyPr wrap="square" lIns="0" rIns="0" tIns="0" bIns="0">
+            <a:spAutoFit/>
+          </a:bodyPr>
+          <a:lstStyle/>
+          <a:p>
+            <a:pPr algn="l"/>
+            <a:r>
+              <a:rPr sz="900" b="0" i="0" u="none">
+                <a:solidFill>
+                  <a:srgbClr val="52525B"/>
+                </a:solidFill>
+                <a:latin typeface="Inter"/>
+              </a:rPr>
+              <a:t>vs Q1 baseline</a:t>
+            </a:r>
+          </a:p>
+        </p:txBody>
+      </p:sp>
+      <p:sp>
+        <p:nvSpPr>
+          <p:cNvPr id="16" name="TextBox 15"/>
+          <p:cNvSpPr txBox="1"/>
+          <p:nvPr/>
+        </p:nvSpPr>
+        <p:spPr>
+          <a:xfrm>
+            <a:off x="4708475" y="4522291"/>
+            <a:ext cx="2774900" cy="781645"/>
+          </a:xfrm>
+          <a:prstGeom prst="rect">
+            <a:avLst/>
+          </a:prstGeom>
+          <a:noFill/>
+        </p:spPr>
+        <p:txBody>
+          <a:bodyPr wrap="square" lIns="0" rIns="0" tIns="0" bIns="0">
+            <a:spAutoFit/>
+          </a:bodyPr>
+          <a:lstStyle/>
+          <a:p>
+            <a:pPr algn="l"/>
+            <a:r>
+              <a:rPr sz="1050" b="0" i="0" u="none">
+                <a:solidFill>
+                  <a:srgbClr val="A1A1AA"/>
+                </a:solidFill>
+                <a:latin typeface="Inter"/>
+              </a:rPr>
+              <a:t>P95 conversion time on a single 8-core box, no GPU. Bottleneck is render parallelism (Chart.js init).</a:t>
+            </a:r>
+          </a:p>
+        </p:txBody>
+      </p:sp>
+      <p:sp>
+        <p:nvSpPr>
+          <p:cNvPr id="17" name="Rounded Rectangle 16"/>
+          <p:cNvSpPr/>
+          <p:nvPr/>
+        </p:nvSpPr>
+        <p:spPr>
+          <a:gradFill flip="none" rotWithShape="1">
+            <a:gsLst>
+              <a:gs pos="0">
+                <a:srgbClr val="FFFFFF">
+                  <a:alpha val="5000"/>
+                </a:srgbClr>
+              </a:gs>
+              <a:gs pos="100000">
+                <a:srgbClr val="FFFFFF">
+                  <a:alpha val="2000"/>
+                </a:srgbClr>
+              </a:gs>
+            </a:gsLst>
+            <a:lin ang="5400000" scaled="0"/>
+          </a:gradFill>
+          <a:xfrm>
+            <a:off x="8026301" y="2502991"/>
+            <a:ext cx="3403699" cy="3153370"/>
+          </a:xfrm>
+          <a:prstGeom prst="roundRect">
+            <a:avLst/>
+          </a:prstGeom>
+          <a:ln w="9525">
+            <a:solidFill>
+              <a:srgbClr val="FFFFFF"/>
+            </a:solidFill>
+          </a:ln>
+          <a:effectLst>
+            <a:outerShdw blurRad="571500" dist="228600" dir="5400000" algn="ctr" rotWithShape="0">
+              <a:srgbClr val="6366F1">
+                <a:alpha val="8000"/>
+              </a:srgbClr>
+            </a:outerShdw>
+          </a:effectLst>
+        </p:spPr>
+        <p:style>
+          <a:lnRef idx="1">
+            <a:schemeClr val="accent1"/>
+          </a:lnRef>
+          <a:fillRef idx="3">
+            <a:schemeClr val="accent1"/>
+          </a:fillRef>
+          <a:effectRef idx="2">
+            <a:schemeClr val="accent1"/>
+          </a:effectRef>
+          <a:fontRef idx="minor">
+            <a:schemeClr val="lt1"/>
+          </a:fontRef>
+        </p:style>
+        <p:txBody>
+          <a:bodyPr rtlCol="0" anchor="ctr"/>
+          <a:lstStyle/>
+          <a:p>
+            <a:pPr algn="ctr"/>
+          </a:p>
+        </p:txBody>
+      </p:sp>
+      <p:sp>
+        <p:nvSpPr>
+          <p:cNvPr id="18" name="TextBox 17"/>
+          <p:cNvSpPr txBox="1"/>
+          <p:nvPr/>
+        </p:nvSpPr>
+        <p:spPr>
+          <a:xfrm>
+            <a:off x="8340626" y="2855416"/>
+            <a:ext cx="2775049" cy="152400"/>
+          </a:xfrm>
+          <a:prstGeom prst="rect">
+            <a:avLst/>
+          </a:prstGeom>
+          <a:noFill/>
+        </p:spPr>
+        <p:txBody>
+          <a:bodyPr wrap="square" lIns="0" rIns="0" tIns="0" bIns="0">
+            <a:spAutoFit/>
+          </a:bodyPr>
+          <a:lstStyle/>
+          <a:p>
+            <a:pPr algn="l"/>
+            <a:r>
+              <a:rPr sz="975" b="1" i="0" u="none">
+                <a:solidFill>
+                  <a:srgbClr val="A1A1AA"/>
+                </a:solidFill>
+                <a:latin typeface="Inter"/>
+              </a:rPr>
+              <a:t>LLM cost</a:t>
+            </a:r>
+          </a:p>
+        </p:txBody>
+      </p:sp>
+      <p:sp>
+        <p:nvSpPr>
+          <p:cNvPr id="19" name="TextBox 18"/>
+          <p:cNvSpPr txBox="1"/>
+          <p:nvPr/>
+        </p:nvSpPr>
+        <p:spPr>
+          <a:xfrm>
+            <a:off x="8340626" y="3141166"/>
+            <a:ext cx="2775049" cy="838200"/>
+          </a:xfrm>
+          <a:prstGeom prst="rect">
+            <a:avLst/>
+          </a:prstGeom>
+          <a:noFill/>
+        </p:spPr>
+        <p:txBody>
+          <a:bodyPr wrap="square" lIns="0" rIns="0" tIns="0" bIns="0">
+            <a:spAutoFit/>
+          </a:bodyPr>
+          <a:lstStyle/>
+          <a:p>
+            <a:pPr algn="l"/>
+            <a:r>
+              <a:rPr sz="6600" b="1" i="0" u="none">
+                <a:solidFill>
+                  <a:srgbClr val="F5F5F7"/>
+                </a:solidFill>
+                <a:latin typeface="Inter"/>
+              </a:rPr>
+              <a:t>$0.04</a:t>
+            </a:r>
+          </a:p>
+        </p:txBody>
+      </p:sp>
+      <p:sp>
+        <p:nvSpPr>
+          <p:cNvPr id="20" name="TextBox 19"/>
+          <p:cNvSpPr txBox="1"/>
+          <p:nvPr/>
+        </p:nvSpPr>
+        <p:spPr>
+          <a:xfrm>
+            <a:off x="8340626" y="4112716"/>
+            <a:ext cx="658267" cy="238125"/>
+          </a:xfrm>
+          <a:prstGeom prst="rect">
+            <a:avLst/>
+          </a:prstGeom>
+          <a:solidFill>
+            <a:srgbClr val="F43F5E"/>
+          </a:solidFill>
+        </p:spPr>
+        <p:txBody>
+          <a:bodyPr wrap="square" lIns="0" rIns="0" tIns="0" bIns="0">
+            <a:spAutoFit/>
+          </a:bodyPr>
+          <a:lstStyle/>
+          <a:p>
+            <a:pPr algn="l"/>
+            <a:r>
+              <a:rPr sz="900" b="1" i="0" u="none">
+                <a:solidFill>
+                  <a:srgbClr val="FDA4AF"/>
+                </a:solidFill>
+                <a:latin typeface="Inter"/>
+              </a:rPr>
+              <a:t>▼ -73%</a:t>
+            </a:r>
+          </a:p>
+        </p:txBody>
+      </p:sp>
+      <p:sp>
+        <p:nvSpPr>
+          <p:cNvPr id="21" name="TextBox 20"/>
+          <p:cNvSpPr txBox="1"/>
+          <p:nvPr/>
+        </p:nvSpPr>
+        <p:spPr>
+          <a:xfrm>
+            <a:off x="9075093" y="4160341"/>
+            <a:ext cx="774650" cy="142875"/>
+          </a:xfrm>
+          <a:prstGeom prst="rect">
+            <a:avLst/>
+          </a:prstGeom>
+          <a:noFill/>
+        </p:spPr>
+        <p:txBody>
+          <a:bodyPr wrap="square" lIns="0" rIns="0" tIns="0" bIns="0">
+            <a:spAutoFit/>
+          </a:bodyPr>
+          <a:lstStyle/>
+          <a:p>
+            <a:pPr algn="l"/>
+            <a:r>
+              <a:rPr sz="900" b="0" i="0" u="none">
+                <a:solidFill>
+                  <a:srgbClr val="52525B"/>
+                </a:solidFill>
+                <a:latin typeface="Inter"/>
+              </a:rPr>
+              <a:t>vs Q1 baseline</a:t>
+            </a:r>
+          </a:p>
+        </p:txBody>
+      </p:sp>
+      <p:sp>
+        <p:nvSpPr>
+          <p:cNvPr id="22" name="TextBox 21"/>
+          <p:cNvSpPr txBox="1"/>
+          <p:nvPr/>
+        </p:nvSpPr>
+        <p:spPr>
+          <a:xfrm>
+            <a:off x="8340626" y="4522291"/>
+            <a:ext cx="2775049" cy="781645"/>
+          </a:xfrm>
+          <a:prstGeom prst="rect">
+            <a:avLst/>
+          </a:prstGeom>
+          <a:noFill/>
+        </p:spPr>
+        <p:txBody>
+          <a:bodyPr wrap="square" lIns="0" rIns="0" tIns="0" bIns="0">
+            <a:spAutoFit/>
+          </a:bodyPr>
+          <a:lstStyle/>
+          <a:p>
+            <a:pPr algn="l"/>
+            <a:r>
+              <a:rPr sz="1050" b="0" i="0" u="none">
+                <a:solidFill>
+                  <a:srgbClr val="A1A1AA"/>
+                </a:solidFill>
+                <a:latin typeface="Inter"/>
+              </a:rPr>
+              <a:t>Switch to Gemini Flash + only-firing-on-the-ambiguous-tail. ≤$0.10/deck even with full Tier-3 enabled.</a:t>
+            </a:r>
+          </a:p>
+        </p:txBody>
+      </p:sp>
+      <p:sp>
+        <p:nvSpPr>
+          <p:cNvPr id="23" name="TextBox 22"/>
+          <p:cNvSpPr txBox="1"/>
+          <p:nvPr/>
+        </p:nvSpPr>
+        <p:spPr>
+          <a:xfrm>
+            <a:off x="762000" y="6400800"/>
+            <a:ext cx="3403104" cy="152400"/>
+          </a:xfrm>
+          <a:prstGeom prst="rect">
+            <a:avLst/>
+          </a:prstGeom>
+          <a:noFill/>
+        </p:spPr>
+        <p:txBody>
+          <a:bodyPr wrap="square" lIns="0" rIns="0" tIns="0" bIns="0">
+            <a:spAutoFit/>
+          </a:bodyPr>
+          <a:lstStyle/>
+          <a:p>
+            <a:pPr algn="l"/>
+            <a:r>
+              <a:rPr sz="975" b="1" i="0" u="none">
+                <a:solidFill>
+                  <a:srgbClr val="52525B"/>
+                </a:solidFill>
+                <a:latin typeface="Inter"/>
+              </a:rPr>
+              <a:t>SOURCE · Internal benchmark · April 2026</a:t>
+            </a:r>
+          </a:p>
+        </p:txBody>
+      </p:sp>
+      <p:sp>
+        <p:nvSpPr>
+          <p:cNvPr id="24" name="TextBox 23"/>
+          <p:cNvSpPr txBox="1"/>
+          <p:nvPr/>
+        </p:nvSpPr>
+        <p:spPr>
+          <a:xfrm>
+            <a:off x="10871002" y="6400800"/>
+            <a:ext cx="558998" cy="152400"/>
+          </a:xfrm>
+          <a:prstGeom prst="rect">
+            <a:avLst/>
+          </a:prstGeom>
+          <a:noFill/>
+        </p:spPr>
+        <p:txBody>
+          <a:bodyPr wrap="square" lIns="0" rIns="0" tIns="0" bIns="0">
+            <a:spAutoFit/>
+          </a:bodyPr>
+          <a:lstStyle/>
+          <a:p>
+            <a:pPr algn="l"/>
+            <a:r>
+              <a:rPr sz="975" b="1" i="0" u="none">
+                <a:solidFill>
+                  <a:srgbClr val="52525B"/>
+                </a:solidFill>
+                <a:latin typeface="Inter"/>
+              </a:rPr>
+              <a:t>04 / 12</a:t>
+            </a:r>
+          </a:p>
+        </p:txBody>
+      </p:sp>
+    </p:spTree>
+  </p:cSld>
+  <p:clrMapOvr>
+    <a:masterClrMapping/>
+  </p:clrMapOvr>
+</p:sld>
+</file>
+
+<file path=ppt/slides/slide5.xml><?xml version="1.0" encoding="utf-8"?>
+<p:sld xmlns:a="http://schemas.openxmlformats.org/drawingml/2006/main" xmlns:p="http://schemas.openxmlformats.org/presentationml/2006/main" xmlns:r="http://schemas.openxmlformats.org/officeDocument/2006/relationships">
+  <p:cSld>
+    <p:spTree>
+      <p:nvGrpSpPr>
+        <p:cNvPr id="1" name=""/>
+        <p:cNvGrpSpPr/>
+        <p:nvPr/>
+      </p:nvGrpSpPr>
+      <p:grpSpPr/>
+      <p:sp>
+        <p:nvSpPr>
+          <p:cNvPr id="2" name="Rectangle 1"/>
+          <p:cNvSpPr/>
+          <p:nvPr/>
+        </p:nvSpPr>
+        <p:spPr>
+          <a:xfrm>
+            <a:off x="0" y="0"/>
+            <a:ext cx="12192000" cy="6858000"/>
+          </a:xfrm>
+          <a:prstGeom prst="rect">
+            <a:avLst/>
+          </a:prstGeom>
+          <a:solidFill>
+            <a:srgbClr val="070710"/>
+          </a:solidFill>
+          <a:ln>
+            <a:noFill/>
+          </a:ln>
+        </p:spPr>
+        <p:style>
+          <a:lnRef idx="1">
+            <a:schemeClr val="accent1"/>
+          </a:lnRef>
+          <a:fillRef idx="3">
+            <a:schemeClr val="accent1"/>
+          </a:fillRef>
+          <a:effectRef idx="2">
+            <a:schemeClr val="accent1"/>
+          </a:effectRef>
+          <a:fontRef idx="minor">
+            <a:schemeClr val="lt1"/>
+          </a:fontRef>
+        </p:style>
+        <p:txBody>
+          <a:bodyPr rtlCol="0" anchor="ctr"/>
+          <a:lstStyle/>
+          <a:p>
+            <a:pPr algn="ctr"/>
+          </a:p>
+        </p:txBody>
+      </p:sp>
+      <p:sp>
+        <p:nvSpPr>
+          <p:cNvPr id="3" name="TextBox 2"/>
+          <p:cNvSpPr txBox="1"/>
+          <p:nvPr/>
+        </p:nvSpPr>
+        <p:spPr>
+          <a:xfrm>
+            <a:off x="762000" y="685800"/>
+            <a:ext cx="7020967" cy="439936"/>
+          </a:xfrm>
+          <a:prstGeom prst="rect">
+            <a:avLst/>
+          </a:prstGeom>
+          <a:noFill/>
+        </p:spPr>
+        <p:txBody>
+          <a:bodyPr wrap="square" lIns="0" rIns="0" tIns="0" bIns="0">
+            <a:spAutoFit/>
+          </a:bodyPr>
+          <a:lstStyle/>
+          <a:p>
+            <a:pPr algn="l"/>
+            <a:r>
+              <a:rPr sz="3300" b="1" i="0" u="none">
+                <a:solidFill>
+                  <a:srgbClr val="F5F5F7"/>
+                </a:solidFill>
+                <a:latin typeface="Inter"/>
+              </a:rPr>
+              <a:t>Six pillars of the rendering pipeline.</a:t>
+            </a:r>
+          </a:p>
+        </p:txBody>
+      </p:sp>
+      <p:sp>
+        <p:nvSpPr>
+          <p:cNvPr id="4" name="TextBox 3"/>
+          <p:cNvSpPr txBox="1"/>
+          <p:nvPr/>
+        </p:nvSpPr>
+        <p:spPr>
+          <a:xfrm>
+            <a:off x="10875466" y="973336"/>
+            <a:ext cx="554534" cy="152400"/>
+          </a:xfrm>
+          <a:prstGeom prst="rect">
+            <a:avLst/>
+          </a:prstGeom>
+          <a:noFill/>
+        </p:spPr>
+        <p:txBody>
+          <a:bodyPr wrap="square" lIns="0" rIns="0" tIns="0" bIns="0">
+            <a:spAutoFit/>
+          </a:bodyPr>
+          <a:lstStyle/>
+          <a:p>
+            <a:pPr algn="l"/>
+            <a:r>
+              <a:rPr sz="975" b="1" i="0" u="none">
+                <a:solidFill>
+                  <a:srgbClr val="71717A"/>
+                </a:solidFill>
+                <a:latin typeface="Inter"/>
+              </a:rPr>
+              <a:t>05 / 12</a:t>
+            </a:r>
+          </a:p>
+        </p:txBody>
+      </p:sp>
+      <p:sp>
+        <p:nvSpPr>
+          <p:cNvPr id="5" name="Rounded Rectangle 4"/>
+          <p:cNvSpPr/>
+          <p:nvPr/>
+        </p:nvSpPr>
+        <p:spPr>
+          <a:xfrm>
+            <a:off x="762000" y="1468636"/>
+            <a:ext cx="3429000" cy="2261443"/>
+          </a:xfrm>
+          <a:prstGeom prst="roundRect">
+            <a:avLst/>
+          </a:prstGeom>
+          <a:solidFill>
+            <a:srgbClr val="FFFFFF"/>
+          </a:solidFill>
+          <a:ln w="9525">
+            <a:solidFill>
+              <a:srgbClr val="FFFFFF"/>
+            </a:solidFill>
+          </a:ln>
+          <a:effectLst>
+            <a:outerShdw blurRad="381000" dist="114300" dir="5400000" algn="ctr" rotWithShape="0">
+              <a:srgbClr val="6366F1">
+                <a:alpha val="6000"/>
+              </a:srgbClr>
+            </a:outerShdw>
+          </a:effectLst>
+        </p:spPr>
+        <p:style>
+          <a:lnRef idx="1">
+            <a:schemeClr val="accent1"/>
+          </a:lnRef>
+          <a:fillRef idx="3">
+            <a:schemeClr val="accent1"/>
+          </a:fillRef>
+          <a:effectRef idx="2">
+            <a:schemeClr val="accent1"/>
+          </a:effectRef>
+          <a:fontRef idx="minor">
+            <a:schemeClr val="lt1"/>
+          </a:fontRef>
+        </p:style>
+        <p:txBody>
+          <a:bodyPr rtlCol="0" anchor="ctr"/>
+          <a:lstStyle/>
+          <a:p>
+            <a:pPr algn="ctr"/>
+          </a:p>
+        </p:txBody>
+      </p:sp>
+      <p:sp>
+        <p:nvSpPr>
+          <p:cNvPr id="6" name="TextBox 5"/>
+          <p:cNvSpPr txBox="1"/>
+          <p:nvPr/>
+        </p:nvSpPr>
+        <p:spPr>
+          <a:gradFill flip="none" rotWithShape="1">
+            <a:gsLst>
+              <a:gs pos="0">
+                <a:srgbClr val="6366F1"/>
+              </a:gs>
+              <a:gs pos="100000">
+                <a:srgbClr val="8B5CF6"/>
+              </a:gs>
+            </a:gsLst>
+            <a:lin ang="2700000" scaled="0"/>
+          </a:gradFill>
+          <a:xfrm>
+            <a:off x="1019175" y="1725811"/>
+            <a:ext cx="419100" cy="419100"/>
+          </a:xfrm>
+          <a:prstGeom prst="rect">
+            <a:avLst/>
+          </a:prstGeom>
+        </p:spPr>
+        <p:txBody>
+          <a:bodyPr wrap="square" lIns="0" rIns="0" tIns="0" bIns="0">
+            <a:spAutoFit/>
+          </a:bodyPr>
+          <a:lstStyle/>
+          <a:p>
+            <a:pPr algn="l"/>
+            <a:r>
+              <a:rPr sz="1650" b="1" i="0" u="none">
+                <a:solidFill>
+                  <a:srgbClr val="FFFFFF"/>
+                </a:solidFill>
+                <a:latin typeface="Inter"/>
+              </a:rPr>
+              <a:t>▦</a:t>
+            </a:r>
+          </a:p>
+        </p:txBody>
+      </p:sp>
+      <p:sp>
+        <p:nvSpPr>
+          <p:cNvPr id="7" name="TextBox 6"/>
+          <p:cNvSpPr txBox="1"/>
+          <p:nvPr/>
+        </p:nvSpPr>
+        <p:spPr>
+          <a:xfrm>
+            <a:off x="1019175" y="2373511"/>
+            <a:ext cx="2914650" cy="200025"/>
+          </a:xfrm>
+          <a:prstGeom prst="rect">
+            <a:avLst/>
+          </a:prstGeom>
+          <a:noFill/>
+        </p:spPr>
+        <p:txBody>
+          <a:bodyPr wrap="square" lIns="0" rIns="0" tIns="0" bIns="0">
+            <a:spAutoFit/>
+          </a:bodyPr>
+          <a:lstStyle/>
+          <a:p>
+            <a:pPr algn="l"/>
+            <a:r>
+              <a:rPr sz="1350" b="1" i="0" u="none">
+                <a:solidFill>
+                  <a:srgbClr val="F5F5F7"/>
+                </a:solidFill>
+                <a:latin typeface="Inter"/>
+              </a:rPr>
+              <a:t>Render before decide</a:t>
+            </a:r>
+          </a:p>
+        </p:txBody>
+      </p:sp>
+      <p:sp>
+        <p:nvSpPr>
+          <p:cNvPr id="8" name="TextBox 7"/>
+          <p:cNvSpPr txBox="1"/>
+          <p:nvPr/>
+        </p:nvSpPr>
+        <p:spPr>
+          <a:xfrm>
+            <a:off x="1019175" y="2630686"/>
+            <a:ext cx="2914650" cy="575518"/>
+          </a:xfrm>
+          <a:prstGeom prst="rect">
+            <a:avLst/>
+          </a:prstGeom>
+          <a:noFill/>
+        </p:spPr>
+        <p:txBody>
+          <a:bodyPr wrap="square" lIns="0" rIns="0" tIns="0" bIns="0">
+            <a:spAutoFit/>
+          </a:bodyPr>
+          <a:lstStyle/>
+          <a:p>
+            <a:pPr algn="l"/>
+            <a:r>
+              <a:rPr sz="975" b="0" i="0" u="none">
+                <a:solidFill>
+                  <a:srgbClr val="A1A1AA"/>
+                </a:solidFill>
+                <a:latin typeface="Inter"/>
+              </a:rPr>
+              <a:t>Real Chromium computes the layout. Static analysis cannot resolve flex / grid / flow geometry.</a:t>
+            </a:r>
+          </a:p>
+        </p:txBody>
+      </p:sp>
+      <p:sp>
+        <p:nvSpPr>
+          <p:cNvPr id="9" name="TextBox 8"/>
+          <p:cNvSpPr txBox="1"/>
+          <p:nvPr/>
+        </p:nvSpPr>
+        <p:spPr>
+          <a:xfrm>
+            <a:off x="1019175" y="3206204"/>
+            <a:ext cx="2914650" cy="266700"/>
+          </a:xfrm>
+          <a:prstGeom prst="rect">
+            <a:avLst/>
+          </a:prstGeom>
+          <a:noFill/>
+        </p:spPr>
+        <p:txBody>
+          <a:bodyPr wrap="square" lIns="0" rIns="0" tIns="0" bIns="0">
+            <a:spAutoFit/>
+          </a:bodyPr>
+          <a:lstStyle/>
+          <a:p>
+            <a:pPr algn="l"/>
+            <a:r>
+              <a:rPr sz="825" b="1" i="0" u="none">
+                <a:solidFill>
+                  <a:srgbClr val="52525B"/>
+                </a:solidFill>
+                <a:latin typeface="Inter"/>
+              </a:rPr>
+              <a:t>PLAYWRIGHT</a:t>
+            </a:r>
+          </a:p>
+        </p:txBody>
+      </p:sp>
+      <p:sp>
+        <p:nvSpPr>
+          <p:cNvPr id="10" name="Rounded Rectangle 9"/>
+          <p:cNvSpPr/>
+          <p:nvPr/>
+        </p:nvSpPr>
+        <p:spPr>
+          <a:xfrm>
+            <a:off x="4381500" y="1468636"/>
+            <a:ext cx="3429000" cy="2261443"/>
+          </a:xfrm>
+          <a:prstGeom prst="roundRect">
+            <a:avLst/>
+          </a:prstGeom>
+          <a:solidFill>
+            <a:srgbClr val="FFFFFF"/>
+          </a:solidFill>
+          <a:ln w="9525">
+            <a:solidFill>
+              <a:srgbClr val="FFFFFF"/>
+            </a:solidFill>
+          </a:ln>
+          <a:effectLst>
+            <a:outerShdw blurRad="381000" dist="114300" dir="5400000" algn="ctr" rotWithShape="0">
+              <a:srgbClr val="6366F1">
+                <a:alpha val="6000"/>
+              </a:srgbClr>
+            </a:outerShdw>
+          </a:effectLst>
+        </p:spPr>
+        <p:style>
+          <a:lnRef idx="1">
+            <a:schemeClr val="accent1"/>
+          </a:lnRef>
+          <a:fillRef idx="3">
+            <a:schemeClr val="accent1"/>
+          </a:fillRef>
+          <a:effectRef idx="2">
+            <a:schemeClr val="accent1"/>
+          </a:effectRef>
+          <a:fontRef idx="minor">
+            <a:schemeClr val="lt1"/>
+          </a:fontRef>
+        </p:style>
+        <p:txBody>
+          <a:bodyPr rtlCol="0" anchor="ctr"/>
+          <a:lstStyle/>
+          <a:p>
+            <a:pPr algn="ctr"/>
+          </a:p>
+        </p:txBody>
+      </p:sp>
+      <p:sp>
+        <p:nvSpPr>
+          <p:cNvPr id="11" name="TextBox 10"/>
+          <p:cNvSpPr txBox="1"/>
+          <p:nvPr/>
+        </p:nvSpPr>
+        <p:spPr>
+          <a:gradFill flip="none" rotWithShape="1">
+            <a:gsLst>
+              <a:gs pos="0">
+                <a:srgbClr val="8B5CF6"/>
+              </a:gs>
+              <a:gs pos="100000">
+                <a:srgbClr val="EC4899"/>
+              </a:gs>
+            </a:gsLst>
+            <a:lin ang="2700000" scaled="0"/>
+          </a:gradFill>
+          <a:xfrm>
+            <a:off x="4638675" y="1725811"/>
+            <a:ext cx="419100" cy="419100"/>
+          </a:xfrm>
+          <a:prstGeom prst="rect">
+            <a:avLst/>
+          </a:prstGeom>
+        </p:spPr>
+        <p:txBody>
+          <a:bodyPr wrap="square" lIns="0" rIns="0" tIns="0" bIns="0">
+            <a:spAutoFit/>
+          </a:bodyPr>
+          <a:lstStyle/>
+          <a:p>
+            <a:pPr algn="l"/>
+            <a:r>
+              <a:rPr sz="1650" b="1" i="0" u="none">
+                <a:solidFill>
+                  <a:srgbClr val="FFFFFF"/>
+                </a:solidFill>
+                <a:latin typeface="Inter"/>
+              </a:rPr>
+              <a:t>◈</a:t>
+            </a:r>
+          </a:p>
+        </p:txBody>
+      </p:sp>
+      <p:sp>
+        <p:nvSpPr>
+          <p:cNvPr id="12" name="TextBox 11"/>
+          <p:cNvSpPr txBox="1"/>
+          <p:nvPr/>
+        </p:nvSpPr>
+        <p:spPr>
+          <a:xfrm>
+            <a:off x="4638675" y="2373511"/>
+            <a:ext cx="2914650" cy="200025"/>
+          </a:xfrm>
+          <a:prstGeom prst="rect">
+            <a:avLst/>
+          </a:prstGeom>
+          <a:noFill/>
+        </p:spPr>
+        <p:txBody>
+          <a:bodyPr wrap="square" lIns="0" rIns="0" tIns="0" bIns="0">
+            <a:spAutoFit/>
+          </a:bodyPr>
+          <a:lstStyle/>
+          <a:p>
+            <a:pPr algn="l"/>
+            <a:r>
+              <a:rPr sz="1350" b="1" i="0" u="none">
+                <a:solidFill>
+                  <a:srgbClr val="F5F5F7"/>
+                </a:solidFill>
+                <a:latin typeface="Inter"/>
+              </a:rPr>
+              <a:t>Visual units, not DOM</a:t>
+            </a:r>
+          </a:p>
+        </p:txBody>
+      </p:sp>
+      <p:sp>
+        <p:nvSpPr>
+          <p:cNvPr id="13" name="TextBox 12"/>
+          <p:cNvSpPr txBox="1"/>
+          <p:nvPr/>
+        </p:nvSpPr>
+        <p:spPr>
+          <a:xfrm>
+            <a:off x="4638675" y="2630686"/>
+            <a:ext cx="2914650" cy="383679"/>
+          </a:xfrm>
+          <a:prstGeom prst="rect">
+            <a:avLst/>
+          </a:prstGeom>
+          <a:noFill/>
+        </p:spPr>
+        <p:txBody>
+          <a:bodyPr wrap="square" lIns="0" rIns="0" tIns="0" bIns="0">
+            <a:spAutoFit/>
+          </a:bodyPr>
+          <a:lstStyle/>
+          <a:p>
+            <a:pPr algn="l"/>
+            <a:r>
+              <a:rPr sz="975" b="0" i="0" u="none">
+                <a:solidFill>
+                  <a:srgbClr val="A1A1AA"/>
+                </a:solidFill>
+                <a:latin typeface="Inter"/>
+              </a:rPr>
+              <a:t>Classification atom is a connected visual region — a card, a bullet, a chart — not a single tag.</a:t>
+            </a:r>
+          </a:p>
+        </p:txBody>
+      </p:sp>
+      <p:sp>
+        <p:nvSpPr>
+          <p:cNvPr id="14" name="TextBox 13"/>
+          <p:cNvSpPr txBox="1"/>
+          <p:nvPr/>
+        </p:nvSpPr>
+        <p:spPr>
+          <a:xfrm>
+            <a:off x="4638675" y="3206204"/>
+            <a:ext cx="2914650" cy="266700"/>
+          </a:xfrm>
+          <a:prstGeom prst="rect">
+            <a:avLst/>
+          </a:prstGeom>
+          <a:noFill/>
+        </p:spPr>
+        <p:txBody>
+          <a:bodyPr wrap="square" lIns="0" rIns="0" tIns="0" bIns="0">
+            <a:spAutoFit/>
+          </a:bodyPr>
+          <a:lstStyle/>
+          <a:p>
+            <a:pPr algn="l"/>
+            <a:r>
+              <a:rPr sz="825" b="1" i="0" u="none">
+                <a:solidFill>
+                  <a:srgbClr val="52525B"/>
+                </a:solidFill>
+                <a:latin typeface="Inter"/>
+              </a:rPr>
+              <a:t>CLUSTERER</a:t>
+            </a:r>
+          </a:p>
+        </p:txBody>
+      </p:sp>
+      <p:sp>
+        <p:nvSpPr>
+          <p:cNvPr id="15" name="Rounded Rectangle 14"/>
+          <p:cNvSpPr/>
+          <p:nvPr/>
+        </p:nvSpPr>
+        <p:spPr>
+          <a:xfrm>
+            <a:off x="8001000" y="1468636"/>
+            <a:ext cx="3429000" cy="2261443"/>
+          </a:xfrm>
+          <a:prstGeom prst="roundRect">
+            <a:avLst/>
+          </a:prstGeom>
+          <a:solidFill>
+            <a:srgbClr val="FFFFFF"/>
+          </a:solidFill>
+          <a:ln w="9525">
+            <a:solidFill>
+              <a:srgbClr val="FFFFFF"/>
+            </a:solidFill>
+          </a:ln>
+          <a:effectLst>
+            <a:outerShdw blurRad="381000" dist="114300" dir="5400000" algn="ctr" rotWithShape="0">
+              <a:srgbClr val="6366F1">
+                <a:alpha val="6000"/>
+              </a:srgbClr>
+            </a:outerShdw>
+          </a:effectLst>
+        </p:spPr>
+        <p:style>
+          <a:lnRef idx="1">
+            <a:schemeClr val="accent1"/>
+          </a:lnRef>
+          <a:fillRef idx="3">
+            <a:schemeClr val="accent1"/>
+          </a:fillRef>
+          <a:effectRef idx="2">
+            <a:schemeClr val="accent1"/>
+          </a:effectRef>
+          <a:fontRef idx="minor">
+            <a:schemeClr val="lt1"/>
+          </a:fontRef>
+        </p:style>
+        <p:txBody>
+          <a:bodyPr rtlCol="0" anchor="ctr"/>
+          <a:lstStyle/>
+          <a:p>
+            <a:pPr algn="ctr"/>
+          </a:p>
+        </p:txBody>
+      </p:sp>
+      <p:sp>
+        <p:nvSpPr>
+          <p:cNvPr id="16" name="TextBox 15"/>
+          <p:cNvSpPr txBox="1"/>
+          <p:nvPr/>
+        </p:nvSpPr>
+        <p:spPr>
+          <a:gradFill flip="none" rotWithShape="1">
+            <a:gsLst>
+              <a:gs pos="0">
+                <a:srgbClr val="EC4899"/>
+              </a:gs>
+              <a:gs pos="100000">
+                <a:srgbClr val="F97316"/>
+              </a:gs>
+            </a:gsLst>
+            <a:lin ang="2700000" scaled="0"/>
+          </a:gradFill>
+          <a:xfrm>
+            <a:off x="8258175" y="1725811"/>
+            <a:ext cx="419100" cy="419100"/>
+          </a:xfrm>
+          <a:prstGeom prst="rect">
+            <a:avLst/>
+          </a:prstGeom>
+        </p:spPr>
+        <p:txBody>
+          <a:bodyPr wrap="square" lIns="0" rIns="0" tIns="0" bIns="0">
+            <a:spAutoFit/>
+          </a:bodyPr>
+          <a:lstStyle/>
+          <a:p>
+            <a:pPr algn="l"/>
+            <a:r>
+              <a:rPr sz="1650" b="1" i="0" u="none">
+                <a:solidFill>
+                  <a:srgbClr val="FFFFFF"/>
+                </a:solidFill>
+                <a:latin typeface="Inter"/>
+              </a:rPr>
+              <a:t>⊞</a:t>
+            </a:r>
+          </a:p>
+        </p:txBody>
+      </p:sp>
+      <p:sp>
+        <p:nvSpPr>
+          <p:cNvPr id="17" name="TextBox 16"/>
+          <p:cNvSpPr txBox="1"/>
+          <p:nvPr/>
+        </p:nvSpPr>
+        <p:spPr>
+          <a:xfrm>
+            <a:off x="8258175" y="2373511"/>
+            <a:ext cx="2914650" cy="200025"/>
+          </a:xfrm>
+          <a:prstGeom prst="rect">
+            <a:avLst/>
+          </a:prstGeom>
+          <a:noFill/>
+        </p:spPr>
+        <p:txBody>
+          <a:bodyPr wrap="square" lIns="0" rIns="0" tIns="0" bIns="0">
+            <a:spAutoFit/>
+          </a:bodyPr>
+          <a:lstStyle/>
+          <a:p>
+            <a:pPr algn="l"/>
+            <a:r>
+              <a:rPr sz="1350" b="1" i="0" u="none">
+                <a:solidFill>
+                  <a:srgbClr val="F5F5F7"/>
+                </a:solidFill>
+                <a:latin typeface="Inter"/>
+              </a:rPr>
+              <a:t>Three-tier classifier</a:t>
+            </a:r>
+          </a:p>
+        </p:txBody>
+      </p:sp>
+      <p:sp>
+        <p:nvSpPr>
+          <p:cNvPr id="18" name="TextBox 17"/>
+          <p:cNvSpPr txBox="1"/>
+          <p:nvPr/>
+        </p:nvSpPr>
+        <p:spPr>
+          <a:xfrm>
+            <a:off x="8258175" y="2630686"/>
+            <a:ext cx="2914650" cy="383679"/>
+          </a:xfrm>
+          <a:prstGeom prst="rect">
+            <a:avLst/>
+          </a:prstGeom>
+          <a:noFill/>
+        </p:spPr>
+        <p:txBody>
+          <a:bodyPr wrap="square" lIns="0" rIns="0" tIns="0" bIns="0">
+            <a:spAutoFit/>
+          </a:bodyPr>
+          <a:lstStyle/>
+          <a:p>
+            <a:pPr algn="l"/>
+            <a:r>
+              <a:rPr sz="975" b="0" i="0" u="none">
+                <a:solidFill>
+                  <a:srgbClr val="A1A1AA"/>
+                </a:solidFill>
+                <a:latin typeface="Inter"/>
+              </a:rPr>
+              <a:t>Rules → heuristics → LLM. Closed-vocabulary patterns short-circuit ~90% of decisions.</a:t>
+            </a:r>
+          </a:p>
+        </p:txBody>
+      </p:sp>
+      <p:sp>
+        <p:nvSpPr>
+          <p:cNvPr id="19" name="TextBox 18"/>
+          <p:cNvSpPr txBox="1"/>
+          <p:nvPr/>
+        </p:nvSpPr>
+        <p:spPr>
+          <a:xfrm>
+            <a:off x="8258175" y="3206204"/>
+            <a:ext cx="2914650" cy="266700"/>
+          </a:xfrm>
+          <a:prstGeom prst="rect">
+            <a:avLst/>
+          </a:prstGeom>
+          <a:noFill/>
+        </p:spPr>
+        <p:txBody>
+          <a:bodyPr wrap="square" lIns="0" rIns="0" tIns="0" bIns="0">
+            <a:spAutoFit/>
+          </a:bodyPr>
+          <a:lstStyle/>
+          <a:p>
+            <a:pPr algn="l"/>
+            <a:r>
+              <a:rPr sz="825" b="1" i="0" u="none">
+                <a:solidFill>
+                  <a:srgbClr val="52525B"/>
+                </a:solidFill>
+                <a:latin typeface="Inter"/>
+              </a:rPr>
+              <a:t>TIER 0–3</a:t>
+            </a:r>
+          </a:p>
+        </p:txBody>
+      </p:sp>
+      <p:sp>
+        <p:nvSpPr>
+          <p:cNvPr id="20" name="Rounded Rectangle 19"/>
+          <p:cNvSpPr/>
+          <p:nvPr/>
+        </p:nvSpPr>
+        <p:spPr>
+          <a:xfrm>
+            <a:off x="762000" y="3920579"/>
+            <a:ext cx="3429000" cy="2120057"/>
+          </a:xfrm>
+          <a:prstGeom prst="roundRect">
+            <a:avLst/>
+          </a:prstGeom>
+          <a:solidFill>
+            <a:srgbClr val="FFFFFF"/>
+          </a:solidFill>
+          <a:ln w="9525">
+            <a:solidFill>
+              <a:srgbClr val="FFFFFF"/>
+            </a:solidFill>
+          </a:ln>
+          <a:effectLst>
+            <a:outerShdw blurRad="381000" dist="114300" dir="5400000" algn="ctr" rotWithShape="0">
+              <a:srgbClr val="6366F1">
+                <a:alpha val="6000"/>
+              </a:srgbClr>
+            </a:outerShdw>
+          </a:effectLst>
+        </p:spPr>
+        <p:style>
+          <a:lnRef idx="1">
+            <a:schemeClr val="accent1"/>
+          </a:lnRef>
+          <a:fillRef idx="3">
+            <a:schemeClr val="accent1"/>
+          </a:fillRef>
+          <a:effectRef idx="2">
+            <a:schemeClr val="accent1"/>
+          </a:effectRef>
+          <a:fontRef idx="minor">
+            <a:schemeClr val="lt1"/>
+          </a:fontRef>
+        </p:style>
+        <p:txBody>
+          <a:bodyPr rtlCol="0" anchor="ctr"/>
+          <a:lstStyle/>
+          <a:p>
+            <a:pPr algn="ctr"/>
+          </a:p>
+        </p:txBody>
+      </p:sp>
+      <p:sp>
+        <p:nvSpPr>
+          <p:cNvPr id="21" name="TextBox 20"/>
+          <p:cNvSpPr txBox="1"/>
+          <p:nvPr/>
+        </p:nvSpPr>
+        <p:spPr>
+          <a:gradFill flip="none" rotWithShape="1">
+            <a:gsLst>
+              <a:gs pos="0">
+                <a:srgbClr val="06B6D4"/>
+              </a:gs>
+              <a:gs pos="100000">
+                <a:srgbClr val="6366F1"/>
+              </a:gs>
+            </a:gsLst>
+            <a:lin ang="2700000" scaled="0"/>
+          </a:gradFill>
+          <a:xfrm>
+            <a:off x="1019175" y="4177754"/>
+            <a:ext cx="419100" cy="419100"/>
+          </a:xfrm>
+          <a:prstGeom prst="rect">
+            <a:avLst/>
+          </a:prstGeom>
+        </p:spPr>
+        <p:txBody>
+          <a:bodyPr wrap="square" lIns="0" rIns="0" tIns="0" bIns="0">
+            <a:spAutoFit/>
+          </a:bodyPr>
+          <a:lstStyle/>
+          <a:p>
+            <a:pPr algn="l"/>
+            <a:r>
+              <a:rPr sz="1650" b="1" i="0" u="none">
+                <a:solidFill>
+                  <a:srgbClr val="FFFFFF"/>
+                </a:solidFill>
+                <a:latin typeface="Inter"/>
+              </a:rPr>
+              <a:t>◐</a:t>
+            </a:r>
+          </a:p>
+        </p:txBody>
+      </p:sp>
+      <p:sp>
+        <p:nvSpPr>
+          <p:cNvPr id="22" name="TextBox 21"/>
+          <p:cNvSpPr txBox="1"/>
+          <p:nvPr/>
+        </p:nvSpPr>
+        <p:spPr>
+          <a:xfrm>
+            <a:off x="1019175" y="4825454"/>
+            <a:ext cx="2914650" cy="200025"/>
+          </a:xfrm>
+          <a:prstGeom prst="rect">
+            <a:avLst/>
+          </a:prstGeom>
+          <a:noFill/>
+        </p:spPr>
+        <p:txBody>
+          <a:bodyPr wrap="square" lIns="0" rIns="0" tIns="0" bIns="0">
+            <a:spAutoFit/>
+          </a:bodyPr>
+          <a:lstStyle/>
+          <a:p>
+            <a:pPr algn="l"/>
+            <a:r>
+              <a:rPr sz="1350" b="1" i="0" u="none">
+                <a:solidFill>
+                  <a:srgbClr val="F5F5F7"/>
+                </a:solidFill>
+                <a:latin typeface="Inter"/>
+              </a:rPr>
+              <a:t>Confidence aware</a:t>
+            </a:r>
+          </a:p>
+        </p:txBody>
+      </p:sp>
+      <p:sp>
+        <p:nvSpPr>
+          <p:cNvPr id="23" name="TextBox 22"/>
+          <p:cNvSpPr txBox="1"/>
+          <p:nvPr/>
+        </p:nvSpPr>
+        <p:spPr>
+          <a:xfrm>
+            <a:off x="1019175" y="5082629"/>
+            <a:ext cx="2914650" cy="383679"/>
+          </a:xfrm>
+          <a:prstGeom prst="rect">
+            <a:avLst/>
+          </a:prstGeom>
+          <a:noFill/>
+        </p:spPr>
+        <p:txBody>
+          <a:bodyPr wrap="square" lIns="0" rIns="0" tIns="0" bIns="0">
+            <a:spAutoFit/>
+          </a:bodyPr>
+          <a:lstStyle/>
+          <a:p>
+            <a:pPr algn="l"/>
+            <a:r>
+              <a:rPr sz="975" b="0" i="0" u="none">
+                <a:solidFill>
+                  <a:srgbClr val="A1A1AA"/>
+                </a:solidFill>
+                <a:latin typeface="Inter"/>
+              </a:rPr>
+              <a:t>Every decision carries a confidence score. Low-confidence triggers a dual-emit safety net.</a:t>
+            </a:r>
+          </a:p>
+        </p:txBody>
+      </p:sp>
+      <p:sp>
+        <p:nvSpPr>
+          <p:cNvPr id="24" name="TextBox 23"/>
+          <p:cNvSpPr txBox="1"/>
+          <p:nvPr/>
+        </p:nvSpPr>
+        <p:spPr>
+          <a:xfrm>
+            <a:off x="1019175" y="5516761"/>
+            <a:ext cx="2914650" cy="266700"/>
+          </a:xfrm>
+          <a:prstGeom prst="rect">
+            <a:avLst/>
+          </a:prstGeom>
+          <a:noFill/>
+        </p:spPr>
+        <p:txBody>
+          <a:bodyPr wrap="square" lIns="0" rIns="0" tIns="0" bIns="0">
+            <a:spAutoFit/>
+          </a:bodyPr>
+          <a:lstStyle/>
+          <a:p>
+            <a:pPr algn="l"/>
+            <a:r>
+              <a:rPr sz="825" b="1" i="0" u="none">
+                <a:solidFill>
+                  <a:srgbClr val="52525B"/>
+                </a:solidFill>
+                <a:latin typeface="Inter"/>
+              </a:rPr>
+              <a:t>CONFIDENCE</a:t>
+            </a:r>
+          </a:p>
+        </p:txBody>
+      </p:sp>
+      <p:sp>
+        <p:nvSpPr>
+          <p:cNvPr id="25" name="Rounded Rectangle 24"/>
+          <p:cNvSpPr/>
+          <p:nvPr/>
+        </p:nvSpPr>
+        <p:spPr>
+          <a:xfrm>
+            <a:off x="4381500" y="3920579"/>
+            <a:ext cx="3429000" cy="2120057"/>
+          </a:xfrm>
+          <a:prstGeom prst="roundRect">
+            <a:avLst/>
+          </a:prstGeom>
+          <a:solidFill>
+            <a:srgbClr val="FFFFFF"/>
+          </a:solidFill>
+          <a:ln w="9525">
+            <a:solidFill>
+              <a:srgbClr val="FFFFFF"/>
+            </a:solidFill>
+          </a:ln>
+          <a:effectLst>
+            <a:outerShdw blurRad="381000" dist="114300" dir="5400000" algn="ctr" rotWithShape="0">
+              <a:srgbClr val="6366F1">
+                <a:alpha val="6000"/>
+              </a:srgbClr>
+            </a:outerShdw>
+          </a:effectLst>
+        </p:spPr>
+        <p:style>
+          <a:lnRef idx="1">
+            <a:schemeClr val="accent1"/>
+          </a:lnRef>
+          <a:fillRef idx="3">
+            <a:schemeClr val="accent1"/>
+          </a:fillRef>
+          <a:effectRef idx="2">
+            <a:schemeClr val="accent1"/>
+          </a:effectRef>
+          <a:fontRef idx="minor">
+            <a:schemeClr val="lt1"/>
+          </a:fontRef>
+        </p:style>
+        <p:txBody>
+          <a:bodyPr rtlCol="0" anchor="ctr"/>
+          <a:lstStyle/>
+          <a:p>
+            <a:pPr algn="ctr"/>
+          </a:p>
+        </p:txBody>
+      </p:sp>
+      <p:sp>
+        <p:nvSpPr>
+          <p:cNvPr id="26" name="TextBox 25"/>
+          <p:cNvSpPr txBox="1"/>
+          <p:nvPr/>
+        </p:nvSpPr>
+        <p:spPr>
+          <a:gradFill flip="none" rotWithShape="1">
+            <a:gsLst>
+              <a:gs pos="0">
+                <a:srgbClr val="22C55E"/>
+              </a:gs>
+              <a:gs pos="100000">
+                <a:srgbClr val="06B6D4"/>
+              </a:gs>
+            </a:gsLst>
+            <a:lin ang="2700000" scaled="0"/>
+          </a:gradFill>
+          <a:xfrm>
+            <a:off x="4638675" y="4177754"/>
+            <a:ext cx="419100" cy="419100"/>
+          </a:xfrm>
+          <a:prstGeom prst="rect">
+            <a:avLst/>
+          </a:prstGeom>
+        </p:spPr>
+        <p:txBody>
+          <a:bodyPr wrap="square" lIns="0" rIns="0" tIns="0" bIns="0">
+            <a:spAutoFit/>
+          </a:bodyPr>
+          <a:lstStyle/>
+          <a:p>
+            <a:pPr algn="l"/>
+            <a:r>
+              <a:rPr sz="1650" b="1" i="0" u="none">
+                <a:solidFill>
+                  <a:srgbClr val="FFFFFF"/>
+                </a:solidFill>
+                <a:latin typeface="Inter"/>
+              </a:rPr>
+              <a:t>✓</a:t>
+            </a:r>
+          </a:p>
+        </p:txBody>
+      </p:sp>
+      <p:sp>
+        <p:nvSpPr>
+          <p:cNvPr id="27" name="TextBox 26"/>
+          <p:cNvSpPr txBox="1"/>
+          <p:nvPr/>
+        </p:nvSpPr>
+        <p:spPr>
+          <a:xfrm>
+            <a:off x="4638675" y="4825454"/>
+            <a:ext cx="2914650" cy="200025"/>
+          </a:xfrm>
+          <a:prstGeom prst="rect">
+            <a:avLst/>
+          </a:prstGeom>
+          <a:noFill/>
+        </p:spPr>
+        <p:txBody>
+          <a:bodyPr wrap="square" lIns="0" rIns="0" tIns="0" bIns="0">
+            <a:spAutoFit/>
+          </a:bodyPr>
+          <a:lstStyle/>
+          <a:p>
+            <a:pPr algn="l"/>
+            <a:r>
+              <a:rPr sz="1350" b="1" i="0" u="none">
+                <a:solidFill>
+                  <a:srgbClr val="F5F5F7"/>
+                </a:solidFill>
+                <a:latin typeface="Inter"/>
+              </a:rPr>
+              <a:t>Self validating</a:t>
+            </a:r>
+          </a:p>
+        </p:txBody>
+      </p:sp>
+      <p:sp>
+        <p:nvSpPr>
+          <p:cNvPr id="28" name="TextBox 27"/>
+          <p:cNvSpPr txBox="1"/>
+          <p:nvPr/>
+        </p:nvSpPr>
+        <p:spPr>
+          <a:xfrm>
+            <a:off x="4638675" y="5082629"/>
+            <a:ext cx="2914650" cy="383679"/>
+          </a:xfrm>
+          <a:prstGeom prst="rect">
+            <a:avLst/>
+          </a:prstGeom>
+          <a:noFill/>
+        </p:spPr>
+        <p:txBody>
+          <a:bodyPr wrap="square" lIns="0" rIns="0" tIns="0" bIns="0">
+            <a:spAutoFit/>
+          </a:bodyPr>
+          <a:lstStyle/>
+          <a:p>
+            <a:pPr algn="l"/>
+            <a:r>
+              <a:rPr sz="975" b="0" i="0" u="none">
+                <a:solidFill>
+                  <a:srgbClr val="A1A1AA"/>
+                </a:solidFill>
+                <a:latin typeface="Inter"/>
+              </a:rPr>
+              <a:t>SSIM + OCR oracle catches regressions. Failing regions auto-promote to raster and re-emit.</a:t>
+            </a:r>
+          </a:p>
+        </p:txBody>
+      </p:sp>
+      <p:sp>
+        <p:nvSpPr>
+          <p:cNvPr id="29" name="TextBox 28"/>
+          <p:cNvSpPr txBox="1"/>
+          <p:nvPr/>
+        </p:nvSpPr>
+        <p:spPr>
+          <a:xfrm>
+            <a:off x="4638675" y="5516761"/>
+            <a:ext cx="2914650" cy="266700"/>
+          </a:xfrm>
+          <a:prstGeom prst="rect">
+            <a:avLst/>
+          </a:prstGeom>
+          <a:noFill/>
+        </p:spPr>
+        <p:txBody>
+          <a:bodyPr wrap="square" lIns="0" rIns="0" tIns="0" bIns="0">
+            <a:spAutoFit/>
+          </a:bodyPr>
+          <a:lstStyle/>
+          <a:p>
+            <a:pPr algn="l"/>
+            <a:r>
+              <a:rPr sz="825" b="1" i="0" u="none">
+                <a:solidFill>
+                  <a:srgbClr val="52525B"/>
+                </a:solidFill>
+                <a:latin typeface="Inter"/>
+              </a:rPr>
+              <a:t>ORACLE</a:t>
+            </a:r>
+          </a:p>
+        </p:txBody>
+      </p:sp>
+      <p:sp>
+        <p:nvSpPr>
+          <p:cNvPr id="30" name="Rounded Rectangle 29"/>
+          <p:cNvSpPr/>
+          <p:nvPr/>
+        </p:nvSpPr>
+        <p:spPr>
+          <a:xfrm>
+            <a:off x="8001000" y="3920579"/>
+            <a:ext cx="3429000" cy="2120057"/>
+          </a:xfrm>
+          <a:prstGeom prst="roundRect">
+            <a:avLst/>
+          </a:prstGeom>
+          <a:solidFill>
+            <a:srgbClr val="FFFFFF"/>
+          </a:solidFill>
+          <a:ln w="9525">
+            <a:solidFill>
+              <a:srgbClr val="FFFFFF"/>
+            </a:solidFill>
+          </a:ln>
+          <a:effectLst>
+            <a:outerShdw blurRad="381000" dist="114300" dir="5400000" algn="ctr" rotWithShape="0">
+              <a:srgbClr val="6366F1">
+                <a:alpha val="6000"/>
+              </a:srgbClr>
+            </a:outerShdw>
+          </a:effectLst>
+        </p:spPr>
+        <p:style>
+          <a:lnRef idx="1">
+            <a:schemeClr val="accent1"/>
+          </a:lnRef>
+          <a:fillRef idx="3">
+            <a:schemeClr val="accent1"/>
+          </a:fillRef>
+          <a:effectRef idx="2">
+            <a:schemeClr val="accent1"/>
+          </a:effectRef>
+          <a:fontRef idx="minor">
+            <a:schemeClr val="lt1"/>
+          </a:fontRef>
+        </p:style>
+        <p:txBody>
+          <a:bodyPr rtlCol="0" anchor="ctr"/>
+          <a:lstStyle/>
+          <a:p>
+            <a:pPr algn="ctr"/>
+          </a:p>
+        </p:txBody>
+      </p:sp>
+      <p:sp>
+        <p:nvSpPr>
+          <p:cNvPr id="31" name="TextBox 30"/>
+          <p:cNvSpPr txBox="1"/>
+          <p:nvPr/>
+        </p:nvSpPr>
+        <p:spPr>
+          <a:gradFill flip="none" rotWithShape="1">
+            <a:gsLst>
+              <a:gs pos="0">
+                <a:srgbClr val="F97316"/>
+              </a:gs>
+              <a:gs pos="100000">
+                <a:srgbClr val="FACC15"/>
+              </a:gs>
+            </a:gsLst>
+            <a:lin ang="2700000" scaled="0"/>
+          </a:gradFill>
+          <a:xfrm>
+            <a:off x="8258175" y="4177754"/>
+            <a:ext cx="419100" cy="419100"/>
+          </a:xfrm>
+          <a:prstGeom prst="rect">
+            <a:avLst/>
+          </a:prstGeom>
+        </p:spPr>
+        <p:txBody>
+          <a:bodyPr wrap="square" lIns="0" rIns="0" tIns="0" bIns="0">
+            <a:spAutoFit/>
+          </a:bodyPr>
+          <a:lstStyle/>
+          <a:p>
+            <a:pPr algn="l"/>
+            <a:r>
+              <a:rPr sz="1650" b="1" i="0" u="none">
+                <a:solidFill>
+                  <a:srgbClr val="FFFFFF"/>
+                </a:solidFill>
+                <a:latin typeface="Inter"/>
+              </a:rPr>
+              <a:t>⌘</a:t>
+            </a:r>
+          </a:p>
+        </p:txBody>
+      </p:sp>
+      <p:sp>
+        <p:nvSpPr>
+          <p:cNvPr id="32" name="TextBox 31"/>
+          <p:cNvSpPr txBox="1"/>
+          <p:nvPr/>
+        </p:nvSpPr>
+        <p:spPr>
+          <a:xfrm>
+            <a:off x="8258175" y="4825454"/>
+            <a:ext cx="2914650" cy="200025"/>
+          </a:xfrm>
+          <a:prstGeom prst="rect">
+            <a:avLst/>
+          </a:prstGeom>
+          <a:noFill/>
+        </p:spPr>
+        <p:txBody>
+          <a:bodyPr wrap="square" lIns="0" rIns="0" tIns="0" bIns="0">
+            <a:spAutoFit/>
+          </a:bodyPr>
+          <a:lstStyle/>
+          <a:p>
+            <a:pPr algn="l"/>
+            <a:r>
+              <a:rPr sz="1350" b="1" i="0" u="none">
+                <a:solidFill>
+                  <a:srgbClr val="F5F5F7"/>
+                </a:solidFill>
+                <a:latin typeface="Inter"/>
+              </a:rPr>
+              <a:t>Cache aggressively</a:t>
+            </a:r>
+          </a:p>
+        </p:txBody>
+      </p:sp>
+      <p:sp>
+        <p:nvSpPr>
+          <p:cNvPr id="33" name="TextBox 32"/>
+          <p:cNvSpPr txBox="1"/>
+          <p:nvPr/>
+        </p:nvSpPr>
+        <p:spPr>
+          <a:xfrm>
+            <a:off x="8258175" y="5082629"/>
+            <a:ext cx="2914650" cy="383679"/>
+          </a:xfrm>
+          <a:prstGeom prst="rect">
+            <a:avLst/>
+          </a:prstGeom>
+          <a:noFill/>
+        </p:spPr>
+        <p:txBody>
+          <a:bodyPr wrap="square" lIns="0" rIns="0" tIns="0" bIns="0">
+            <a:spAutoFit/>
+          </a:bodyPr>
+          <a:lstStyle/>
+          <a:p>
+            <a:pPr algn="l"/>
+            <a:r>
+              <a:rPr sz="975" b="0" i="0" u="none">
+                <a:solidFill>
+                  <a:srgbClr val="A1A1AA"/>
+                </a:solidFill>
+                <a:latin typeface="Inter"/>
+              </a:rPr>
+              <a:t>Structural-signature cache hits 60–80% within a generator after warmup. Reuse is free.</a:t>
+            </a:r>
+          </a:p>
+        </p:txBody>
+      </p:sp>
+      <p:sp>
+        <p:nvSpPr>
+          <p:cNvPr id="34" name="TextBox 33"/>
+          <p:cNvSpPr txBox="1"/>
+          <p:nvPr/>
+        </p:nvSpPr>
+        <p:spPr>
+          <a:xfrm>
+            <a:off x="8258175" y="5516761"/>
+            <a:ext cx="2914650" cy="266700"/>
+          </a:xfrm>
+          <a:prstGeom prst="rect">
+            <a:avLst/>
+          </a:prstGeom>
+          <a:noFill/>
+        </p:spPr>
+        <p:txBody>
+          <a:bodyPr wrap="square" lIns="0" rIns="0" tIns="0" bIns="0">
+            <a:spAutoFit/>
+          </a:bodyPr>
+          <a:lstStyle/>
+          <a:p>
+            <a:pPr algn="l"/>
+            <a:r>
+              <a:rPr sz="825" b="1" i="0" u="none">
+                <a:solidFill>
+                  <a:srgbClr val="52525B"/>
+                </a:solidFill>
+                <a:latin typeface="Inter"/>
+              </a:rPr>
+              <a:t>CACHE</a:t>
+            </a:r>
+          </a:p>
+        </p:txBody>
+      </p:sp>
+      <p:sp>
+        <p:nvSpPr>
+          <p:cNvPr id="35" name="TextBox 34"/>
+          <p:cNvSpPr txBox="1"/>
+          <p:nvPr/>
+        </p:nvSpPr>
+        <p:spPr>
+          <a:xfrm>
+            <a:off x="762000" y="6477000"/>
+            <a:ext cx="1411635" cy="152400"/>
+          </a:xfrm>
+          <a:prstGeom prst="rect">
+            <a:avLst/>
+          </a:prstGeom>
+          <a:noFill/>
+        </p:spPr>
+        <p:txBody>
+          <a:bodyPr wrap="square" lIns="0" rIns="0" tIns="0" bIns="0">
+            <a:spAutoFit/>
+          </a:bodyPr>
+          <a:lstStyle/>
+          <a:p>
+            <a:pPr algn="l"/>
+            <a:r>
+              <a:rPr sz="975" b="1" i="0" u="none">
+                <a:solidFill>
+                  <a:srgbClr val="52525B"/>
+                </a:solidFill>
+                <a:latin typeface="Inter"/>
+              </a:rPr>
+              <a:t>PIXELPITCH LABS</a:t>
+            </a:r>
+          </a:p>
+        </p:txBody>
+      </p:sp>
+      <p:sp>
+        <p:nvSpPr>
+          <p:cNvPr id="36" name="TextBox 35"/>
+          <p:cNvSpPr txBox="1"/>
+          <p:nvPr/>
+        </p:nvSpPr>
+        <p:spPr>
+          <a:xfrm>
+            <a:off x="10875466" y="6477000"/>
+            <a:ext cx="554534" cy="152400"/>
+          </a:xfrm>
+          <a:prstGeom prst="rect">
+            <a:avLst/>
+          </a:prstGeom>
+          <a:noFill/>
+        </p:spPr>
+        <p:txBody>
+          <a:bodyPr wrap="square" lIns="0" rIns="0" tIns="0" bIns="0">
+            <a:spAutoFit/>
+          </a:bodyPr>
+          <a:lstStyle/>
+          <a:p>
+            <a:pPr algn="l"/>
+            <a:r>
+              <a:rPr sz="975" b="1" i="0" u="none">
+                <a:solidFill>
+                  <a:srgbClr val="52525B"/>
+                </a:solidFill>
+                <a:latin typeface="Inter"/>
+              </a:rPr>
+              <a:t>05 / 12</a:t>
+            </a:r>
+          </a:p>
+        </p:txBody>
+      </p:sp>
+    </p:spTree>
+  </p:cSld>
+  <p:clrMapOvr>
+    <a:masterClrMapping/>
+  </p:clrMapOvr>
+</p:sld>
+</file>
+
+<file path=ppt/slides/slide6.xml><?xml version="1.0" encoding="utf-8"?>
+<p:sld xmlns:a="http://schemas.openxmlformats.org/drawingml/2006/main" xmlns:p="http://schemas.openxmlformats.org/presentationml/2006/main" xmlns:r="http://schemas.openxmlformats.org/officeDocument/2006/relationships">
+  <p:cSld>
+    <p:spTree>
+      <p:nvGrpSpPr>
+        <p:cNvPr id="1" name=""/>
+        <p:cNvGrpSpPr/>
+        <p:nvPr/>
+      </p:nvGrpSpPr>
+      <p:grpSpPr/>
+      <p:sp>
+        <p:nvSpPr>
+          <p:cNvPr id="2" name="Rectangle 1"/>
+          <p:cNvSpPr/>
+          <p:nvPr/>
+        </p:nvSpPr>
+        <p:spPr>
+          <a:xfrm>
+            <a:off x="0" y="0"/>
+            <a:ext cx="12192000" cy="6858000"/>
+          </a:xfrm>
+          <a:prstGeom prst="rect">
+            <a:avLst/>
+          </a:prstGeom>
+          <a:solidFill>
+            <a:srgbClr val="070710"/>
+          </a:solidFill>
+          <a:ln>
+            <a:noFill/>
+          </a:ln>
+        </p:spPr>
+        <p:style>
+          <a:lnRef idx="1">
+            <a:schemeClr val="accent1"/>
+          </a:lnRef>
+          <a:fillRef idx="3">
+            <a:schemeClr val="accent1"/>
+          </a:fillRef>
+          <a:effectRef idx="2">
+            <a:schemeClr val="accent1"/>
+          </a:effectRef>
+          <a:fontRef idx="minor">
+            <a:schemeClr val="lt1"/>
+          </a:fontRef>
+        </p:style>
+        <p:txBody>
+          <a:bodyPr rtlCol="0" anchor="ctr"/>
+          <a:lstStyle/>
+          <a:p>
+            <a:pPr algn="ctr"/>
+          </a:p>
+        </p:txBody>
+      </p:sp>
+      <p:sp>
+        <p:nvSpPr>
+          <p:cNvPr id="3" name="TextBox 2"/>
+          <p:cNvSpPr txBox="1"/>
+          <p:nvPr/>
+        </p:nvSpPr>
+        <p:spPr>
+          <a:xfrm>
+            <a:off x="762000" y="762000"/>
+            <a:ext cx="10668000" cy="152400"/>
+          </a:xfrm>
+          <a:prstGeom prst="rect">
+            <a:avLst/>
+          </a:prstGeom>
+          <a:noFill/>
+        </p:spPr>
+        <p:txBody>
+          <a:bodyPr wrap="square" lIns="0" rIns="0" tIns="0" bIns="0">
+            <a:spAutoFit/>
+          </a:bodyPr>
+          <a:lstStyle/>
+          <a:p>
+            <a:pPr algn="l"/>
+            <a:r>
+              <a:rPr sz="975" b="1" i="0" u="none">
+                <a:solidFill>
+                  <a:srgbClr val="A78BFA"/>
+                </a:solidFill>
+                <a:latin typeface="Inter"/>
+              </a:rPr>
+              <a:t>Before · After</a:t>
+            </a:r>
+          </a:p>
+        </p:txBody>
+      </p:sp>
+      <p:sp>
+        <p:nvSpPr>
+          <p:cNvPr id="4" name="TextBox 3"/>
+          <p:cNvSpPr txBox="1"/>
+          <p:nvPr/>
+        </p:nvSpPr>
+        <p:spPr>
+          <a:xfrm>
+            <a:off x="762000" y="1085850"/>
+            <a:ext cx="10668000" cy="460028"/>
+          </a:xfrm>
+          <a:prstGeom prst="rect">
+            <a:avLst/>
+          </a:prstGeom>
+          <a:noFill/>
+        </p:spPr>
+        <p:txBody>
+          <a:bodyPr wrap="square" lIns="0" rIns="0" tIns="0" bIns="0">
+            <a:spAutoFit/>
+          </a:bodyPr>
+          <a:lstStyle/>
+          <a:p>
+            <a:pPr algn="l"/>
+            <a:r>
+              <a:rPr sz="3450" b="1" i="0" u="none">
+                <a:solidFill>
+                  <a:srgbClr val="F5F5F7"/>
+                </a:solidFill>
+                <a:latin typeface="Inter"/>
+              </a:rPr>
+              <a:t>Same browser render. Two very different decks.</a:t>
+            </a:r>
+          </a:p>
+        </p:txBody>
+      </p:sp>
+      <p:sp>
+        <p:nvSpPr>
+          <p:cNvPr id="5" name="Rounded Rectangle 4"/>
+          <p:cNvSpPr/>
+          <p:nvPr/>
+        </p:nvSpPr>
+        <p:spPr>
+          <a:xfrm>
+            <a:off x="762000" y="1926878"/>
+            <a:ext cx="5200650" cy="4057650"/>
+          </a:xfrm>
+          <a:prstGeom prst="roundRect">
+            <a:avLst/>
+          </a:prstGeom>
+          <a:solidFill>
+            <a:srgbClr val="3F3F46"/>
+          </a:solidFill>
+          <a:ln w="9525">
+            <a:solidFill>
+              <a:srgbClr val="FFFFFF"/>
+            </a:solidFill>
+          </a:ln>
+        </p:spPr>
+        <p:style>
+          <a:lnRef idx="1">
+            <a:schemeClr val="accent1"/>
+          </a:lnRef>
+          <a:fillRef idx="3">
+            <a:schemeClr val="accent1"/>
+          </a:fillRef>
+          <a:effectRef idx="2">
+            <a:schemeClr val="accent1"/>
+          </a:effectRef>
+          <a:fontRef idx="minor">
+            <a:schemeClr val="lt1"/>
+          </a:fontRef>
+        </p:style>
+        <p:txBody>
+          <a:bodyPr rtlCol="0" anchor="ctr"/>
+          <a:lstStyle/>
+          <a:p>
+            <a:pPr algn="ctr"/>
+          </a:p>
+        </p:txBody>
+      </p:sp>
+      <p:sp>
+        <p:nvSpPr>
+          <p:cNvPr id="6" name="TextBox 5"/>
+          <p:cNvSpPr txBox="1"/>
+          <p:nvPr/>
+        </p:nvSpPr>
+        <p:spPr>
+          <a:xfrm>
+            <a:off x="1114425" y="2279303"/>
+            <a:ext cx="1906786" cy="276225"/>
+          </a:xfrm>
+          <a:prstGeom prst="rect">
+            <a:avLst/>
+          </a:prstGeom>
+          <a:noFill/>
+        </p:spPr>
+        <p:txBody>
+          <a:bodyPr wrap="square" lIns="0" rIns="0" tIns="0" bIns="0">
+            <a:spAutoFit/>
+          </a:bodyPr>
+          <a:lstStyle/>
+          <a:p>
+            <a:pPr algn="l"/>
+            <a:r>
+              <a:rPr sz="1800" b="1" i="0" u="none">
+                <a:solidFill>
+                  <a:srgbClr val="A1A1AA"/>
+                </a:solidFill>
+                <a:latin typeface="Inter"/>
+              </a:rPr>
+              <a:t>Naive screenshot</a:t>
+            </a:r>
+          </a:p>
+        </p:txBody>
+      </p:sp>
+      <p:sp>
+        <p:nvSpPr>
+          <p:cNvPr id="7" name="TextBox 6"/>
+          <p:cNvSpPr txBox="1"/>
+          <p:nvPr/>
+        </p:nvSpPr>
+        <p:spPr>
+          <a:xfrm>
+            <a:off x="4824412" y="2326928"/>
+            <a:ext cx="785812" cy="228600"/>
+          </a:xfrm>
+          <a:prstGeom prst="rect">
+            <a:avLst/>
+          </a:prstGeom>
+          <a:solidFill>
+            <a:srgbClr val="3F3F46"/>
+          </a:solidFill>
+        </p:spPr>
+        <p:txBody>
+          <a:bodyPr wrap="square" lIns="0" rIns="0" tIns="0" bIns="0">
+            <a:spAutoFit/>
+          </a:bodyPr>
+          <a:lstStyle/>
+          <a:p>
+            <a:pPr algn="l"/>
+            <a:r>
+              <a:rPr sz="825" b="1" i="0" u="none">
+                <a:solidFill>
+                  <a:srgbClr val="A1A1AA"/>
+                </a:solidFill>
+                <a:latin typeface="Inter"/>
+              </a:rPr>
+              <a:t>OLD WAY</a:t>
+            </a:r>
+          </a:p>
+        </p:txBody>
+      </p:sp>
+      <p:sp>
+        <p:nvSpPr>
+          <p:cNvPr id="8" name="TextBox 7"/>
+          <p:cNvSpPr txBox="1"/>
+          <p:nvPr/>
+        </p:nvSpPr>
+        <p:spPr>
+          <a:xfrm>
+            <a:off x="1114425" y="3107978"/>
+            <a:ext cx="209550" cy="209550"/>
+          </a:xfrm>
+          <a:prstGeom prst="rect">
+            <a:avLst/>
+          </a:prstGeom>
+          <a:solidFill>
+            <a:srgbClr val="F43F5E"/>
+          </a:solidFill>
+        </p:spPr>
+        <p:txBody>
+          <a:bodyPr wrap="square" lIns="0" rIns="0" tIns="0" bIns="0">
+            <a:spAutoFit/>
+          </a:bodyPr>
+          <a:lstStyle/>
+          <a:p>
+            <a:pPr algn="l"/>
+            <a:r>
+              <a:rPr sz="975" b="1" i="0" u="none">
+                <a:solidFill>
+                  <a:srgbClr val="FDA4AF"/>
+                </a:solidFill>
+                <a:latin typeface="Inter"/>
+              </a:rPr>
+              <a:t>×</a:t>
+            </a:r>
+          </a:p>
+        </p:txBody>
+      </p:sp>
+      <p:sp>
+        <p:nvSpPr>
+          <p:cNvPr id="9" name="TextBox 8"/>
+          <p:cNvSpPr txBox="1"/>
+          <p:nvPr/>
+        </p:nvSpPr>
+        <p:spPr>
+          <a:xfrm>
+            <a:off x="1457325" y="3107978"/>
+            <a:ext cx="3343721" cy="214312"/>
+          </a:xfrm>
+          <a:prstGeom prst="rect">
+            <a:avLst/>
+          </a:prstGeom>
+          <a:noFill/>
+        </p:spPr>
+        <p:txBody>
+          <a:bodyPr wrap="square" lIns="0" rIns="0" tIns="0" bIns="0">
+            <a:spAutoFit/>
+          </a:bodyPr>
+          <a:lstStyle/>
+          <a:p>
+            <a:pPr algn="l"/>
+            <a:r>
+              <a:rPr sz="1125" b="0" i="0" u="none">
+                <a:solidFill>
+                  <a:srgbClr val="A1A1AA"/>
+                </a:solidFill>
+                <a:latin typeface="Inter"/>
+              </a:rPr>
+              <a:t>Every slide is a 50 MB PNG embedded into PPTX.</a:t>
+            </a:r>
+          </a:p>
+        </p:txBody>
+      </p:sp>
+      <p:sp>
+        <p:nvSpPr>
+          <p:cNvPr id="10" name="TextBox 9"/>
+          <p:cNvSpPr txBox="1"/>
+          <p:nvPr/>
+        </p:nvSpPr>
+        <p:spPr>
+          <a:xfrm>
+            <a:off x="1114425" y="3598515"/>
+            <a:ext cx="209550" cy="209550"/>
+          </a:xfrm>
+          <a:prstGeom prst="rect">
+            <a:avLst/>
+          </a:prstGeom>
+          <a:solidFill>
+            <a:srgbClr val="F43F5E"/>
+          </a:solidFill>
+        </p:spPr>
+        <p:txBody>
+          <a:bodyPr wrap="square" lIns="0" rIns="0" tIns="0" bIns="0">
+            <a:spAutoFit/>
+          </a:bodyPr>
+          <a:lstStyle/>
+          <a:p>
+            <a:pPr algn="l"/>
+            <a:r>
+              <a:rPr sz="975" b="1" i="0" u="none">
+                <a:solidFill>
+                  <a:srgbClr val="FDA4AF"/>
+                </a:solidFill>
+                <a:latin typeface="Inter"/>
+              </a:rPr>
+              <a:t>×</a:t>
+            </a:r>
+          </a:p>
+        </p:txBody>
+      </p:sp>
+      <p:sp>
+        <p:nvSpPr>
+          <p:cNvPr id="11" name="TextBox 10"/>
+          <p:cNvSpPr txBox="1"/>
+          <p:nvPr/>
+        </p:nvSpPr>
+        <p:spPr>
+          <a:xfrm>
+            <a:off x="1457325" y="3598515"/>
+            <a:ext cx="3033564" cy="214312"/>
+          </a:xfrm>
+          <a:prstGeom prst="rect">
+            <a:avLst/>
+          </a:prstGeom>
+          <a:noFill/>
+        </p:spPr>
+        <p:txBody>
+          <a:bodyPr wrap="square" lIns="0" rIns="0" tIns="0" bIns="0">
+            <a:spAutoFit/>
+          </a:bodyPr>
+          <a:lstStyle/>
+          <a:p>
+            <a:pPr algn="l"/>
+            <a:r>
+              <a:rPr sz="1125" b="0" i="0" u="none">
+                <a:solidFill>
+                  <a:srgbClr val="A1A1AA"/>
+                </a:solidFill>
+                <a:latin typeface="Inter"/>
+              </a:rPr>
+              <a:t>No text is searchable, selectable, or editable.</a:t>
+            </a:r>
+          </a:p>
+        </p:txBody>
+      </p:sp>
+      <p:sp>
+        <p:nvSpPr>
+          <p:cNvPr id="12" name="TextBox 11"/>
+          <p:cNvSpPr txBox="1"/>
+          <p:nvPr/>
+        </p:nvSpPr>
+        <p:spPr>
+          <a:xfrm>
+            <a:off x="1114425" y="4089053"/>
+            <a:ext cx="209550" cy="209550"/>
+          </a:xfrm>
+          <a:prstGeom prst="rect">
+            <a:avLst/>
+          </a:prstGeom>
+          <a:solidFill>
+            <a:srgbClr val="F43F5E"/>
+          </a:solidFill>
+        </p:spPr>
+        <p:txBody>
+          <a:bodyPr wrap="square" lIns="0" rIns="0" tIns="0" bIns="0">
+            <a:spAutoFit/>
+          </a:bodyPr>
+          <a:lstStyle/>
+          <a:p>
+            <a:pPr algn="l"/>
+            <a:r>
+              <a:rPr sz="975" b="1" i="0" u="none">
+                <a:solidFill>
+                  <a:srgbClr val="FDA4AF"/>
+                </a:solidFill>
+                <a:latin typeface="Inter"/>
+              </a:rPr>
+              <a:t>×</a:t>
+            </a:r>
+          </a:p>
+        </p:txBody>
+      </p:sp>
+      <p:sp>
+        <p:nvSpPr>
+          <p:cNvPr id="13" name="TextBox 12"/>
+          <p:cNvSpPr txBox="1"/>
+          <p:nvPr/>
+        </p:nvSpPr>
+        <p:spPr>
+          <a:xfrm>
+            <a:off x="1457325" y="4089053"/>
+            <a:ext cx="3863727" cy="214312"/>
+          </a:xfrm>
+          <a:prstGeom prst="rect">
+            <a:avLst/>
+          </a:prstGeom>
+          <a:noFill/>
+        </p:spPr>
+        <p:txBody>
+          <a:bodyPr wrap="square" lIns="0" rIns="0" tIns="0" bIns="0">
+            <a:spAutoFit/>
+          </a:bodyPr>
+          <a:lstStyle/>
+          <a:p>
+            <a:r>
+              <a:rPr sz="1125" b="0">
+                <a:solidFill>
+                  <a:srgbClr val="A1A1AA"/>
+                </a:solidFill>
+                <a:latin typeface="Inter"/>
+              </a:rPr>
+              <a:t>• Brand-color swap requires re-running the whole pipeline.</a:t>
+            </a:r>
+          </a:p>
+        </p:txBody>
+      </p:sp>
+      <p:sp>
+        <p:nvSpPr>
+          <p:cNvPr id="14" name="TextBox 13"/>
+          <p:cNvSpPr txBox="1"/>
+          <p:nvPr/>
+        </p:nvSpPr>
+        <p:spPr>
+          <a:xfrm>
+            <a:off x="1114425" y="4579590"/>
+            <a:ext cx="209550" cy="209550"/>
+          </a:xfrm>
+          <a:prstGeom prst="rect">
+            <a:avLst/>
+          </a:prstGeom>
+          <a:solidFill>
+            <a:srgbClr val="F43F5E"/>
+          </a:solidFill>
+        </p:spPr>
+        <p:txBody>
+          <a:bodyPr wrap="square" lIns="0" rIns="0" tIns="0" bIns="0">
+            <a:spAutoFit/>
+          </a:bodyPr>
+          <a:lstStyle/>
+          <a:p>
+            <a:pPr algn="l"/>
+            <a:r>
+              <a:rPr sz="975" b="1" i="0" u="none">
+                <a:solidFill>
+                  <a:srgbClr val="FDA4AF"/>
+                </a:solidFill>
+                <a:latin typeface="Inter"/>
+              </a:rPr>
+              <a:t>×</a:t>
+            </a:r>
+          </a:p>
+        </p:txBody>
+      </p:sp>
+      <p:sp>
+        <p:nvSpPr>
+          <p:cNvPr id="15" name="TextBox 14"/>
+          <p:cNvSpPr txBox="1"/>
+          <p:nvPr/>
+        </p:nvSpPr>
+        <p:spPr>
+          <a:xfrm>
+            <a:off x="1457325" y="4579590"/>
+            <a:ext cx="3637806" cy="214312"/>
+          </a:xfrm>
+          <a:prstGeom prst="rect">
+            <a:avLst/>
+          </a:prstGeom>
+          <a:noFill/>
+        </p:spPr>
+        <p:txBody>
+          <a:bodyPr wrap="square" lIns="0" rIns="0" tIns="0" bIns="0">
+            <a:spAutoFit/>
+          </a:bodyPr>
+          <a:lstStyle/>
+          <a:p>
+            <a:pPr algn="l"/>
+            <a:r>
+              <a:rPr sz="1125" b="0" i="0" u="none">
+                <a:solidFill>
+                  <a:srgbClr val="A1A1AA"/>
+                </a:solidFill>
+                <a:latin typeface="Inter"/>
+              </a:rPr>
+              <a:t>Resizing degrades pixel-by-pixel, especially on retina.</a:t>
+            </a:r>
+          </a:p>
+        </p:txBody>
+      </p:sp>
+      <p:sp>
+        <p:nvSpPr>
+          <p:cNvPr id="16" name="TextBox 15"/>
+          <p:cNvSpPr txBox="1"/>
+          <p:nvPr/>
+        </p:nvSpPr>
+        <p:spPr>
+          <a:xfrm>
+            <a:off x="1114425" y="5070128"/>
+            <a:ext cx="209550" cy="209550"/>
+          </a:xfrm>
+          <a:prstGeom prst="rect">
+            <a:avLst/>
+          </a:prstGeom>
+          <a:solidFill>
+            <a:srgbClr val="F43F5E"/>
+          </a:solidFill>
+        </p:spPr>
+        <p:txBody>
+          <a:bodyPr wrap="square" lIns="0" rIns="0" tIns="0" bIns="0">
+            <a:spAutoFit/>
+          </a:bodyPr>
+          <a:lstStyle/>
+          <a:p>
+            <a:pPr algn="l"/>
+            <a:r>
+              <a:rPr sz="975" b="1" i="0" u="none">
+                <a:solidFill>
+                  <a:srgbClr val="FDA4AF"/>
+                </a:solidFill>
+                <a:latin typeface="Inter"/>
+              </a:rPr>
+              <a:t>×</a:t>
+            </a:r>
+          </a:p>
+        </p:txBody>
+      </p:sp>
+      <p:sp>
+        <p:nvSpPr>
+          <p:cNvPr id="17" name="TextBox 16"/>
+          <p:cNvSpPr txBox="1"/>
+          <p:nvPr/>
+        </p:nvSpPr>
+        <p:spPr>
+          <a:xfrm>
+            <a:off x="1457325" y="5070128"/>
+            <a:ext cx="3885158" cy="214312"/>
+          </a:xfrm>
+          <a:prstGeom prst="rect">
+            <a:avLst/>
+          </a:prstGeom>
+          <a:noFill/>
+        </p:spPr>
+        <p:txBody>
+          <a:bodyPr wrap="square" lIns="0" rIns="0" tIns="0" bIns="0">
+            <a:spAutoFit/>
+          </a:bodyPr>
+          <a:lstStyle/>
+          <a:p>
+            <a:r>
+              <a:rPr sz="1125" b="0">
+                <a:solidFill>
+                  <a:srgbClr val="A1A1AA"/>
+                </a:solidFill>
+                <a:latin typeface="Inter"/>
+              </a:rPr>
+              <a:t>• Translation requires a second model run plus paste-back.</a:t>
+            </a:r>
+          </a:p>
+        </p:txBody>
+      </p:sp>
+      <p:sp>
+        <p:nvSpPr>
+          <p:cNvPr id="18" name="Rounded Rectangle 17"/>
+          <p:cNvSpPr/>
+          <p:nvPr/>
+        </p:nvSpPr>
+        <p:spPr>
+          <a:gradFill flip="none" rotWithShape="1">
+            <a:gsLst>
+              <a:gs pos="0">
+                <a:srgbClr val="6366F1">
+                  <a:alpha val="18000"/>
+                </a:srgbClr>
+              </a:gs>
+              <a:gs pos="100000">
+                <a:srgbClr val="EC4899">
+                  <a:alpha val="10000"/>
+                </a:srgbClr>
+              </a:gs>
+            </a:gsLst>
+            <a:lin ang="4200000" scaled="0"/>
+          </a:gradFill>
+          <a:xfrm>
+            <a:off x="6229350" y="1926878"/>
+            <a:ext cx="5200650" cy="4057650"/>
+          </a:xfrm>
+          <a:prstGeom prst="roundRect">
+            <a:avLst/>
+          </a:prstGeom>
+          <a:ln w="9525">
+            <a:solidFill>
+              <a:srgbClr val="A78BFA"/>
+            </a:solidFill>
+          </a:ln>
+          <a:effectLst>
+            <a:outerShdw blurRad="762000" dist="0" dir="0" algn="ctr" rotWithShape="0">
+              <a:srgbClr val="8B5CF6">
+                <a:alpha val="20000"/>
+              </a:srgbClr>
+            </a:outerShdw>
+          </a:effectLst>
+        </p:spPr>
+        <p:style>
+          <a:lnRef idx="1">
+            <a:schemeClr val="accent1"/>
+          </a:lnRef>
+          <a:fillRef idx="3">
+            <a:schemeClr val="accent1"/>
+          </a:fillRef>
+          <a:effectRef idx="2">
+            <a:schemeClr val="accent1"/>
+          </a:effectRef>
+          <a:fontRef idx="minor">
+            <a:schemeClr val="lt1"/>
+          </a:fontRef>
+        </p:style>
+        <p:txBody>
+          <a:bodyPr rtlCol="0" anchor="ctr"/>
+          <a:lstStyle/>
+          <a:p>
+            <a:pPr algn="ctr"/>
+          </a:p>
+        </p:txBody>
+      </p:sp>
+      <p:sp>
+        <p:nvSpPr>
+          <p:cNvPr id="19" name="TextBox 18"/>
+          <p:cNvSpPr txBox="1"/>
+          <p:nvPr/>
+        </p:nvSpPr>
+        <p:spPr>
+          <a:xfrm>
+            <a:off x="6581775" y="2279303"/>
+            <a:ext cx="674043" cy="276225"/>
+          </a:xfrm>
+          <a:prstGeom prst="rect">
+            <a:avLst/>
+          </a:prstGeom>
+          <a:noFill/>
+        </p:spPr>
+        <p:txBody>
+          <a:bodyPr wrap="square" lIns="0" rIns="0" tIns="0" bIns="0">
+            <a:spAutoFit/>
+          </a:bodyPr>
+          <a:lstStyle/>
+          <a:p>
+            <a:pPr algn="l"/>
+            <a:r>
+              <a:rPr sz="1800" b="1" i="0" u="none">
+                <a:solidFill>
+                  <a:srgbClr val="F5F5F7"/>
+                </a:solidFill>
+                <a:latin typeface="Inter"/>
+              </a:rPr>
+              <a:t>slidify</a:t>
+            </a:r>
+          </a:p>
+        </p:txBody>
+      </p:sp>
+      <p:sp>
+        <p:nvSpPr>
+          <p:cNvPr id="20" name="TextBox 19"/>
+          <p:cNvSpPr txBox="1"/>
+          <p:nvPr/>
+        </p:nvSpPr>
+        <p:spPr>
+          <a:gradFill flip="none" rotWithShape="1">
+            <a:gsLst>
+              <a:gs pos="0">
+                <a:srgbClr val="818CF8"/>
+              </a:gs>
+              <a:gs pos="100000">
+                <a:srgbClr val="F472B6"/>
+              </a:gs>
+            </a:gsLst>
+            <a:lin ang="2700000" scaled="0"/>
+          </a:gradFill>
+          <a:xfrm>
+            <a:off x="10255151" y="2326928"/>
+            <a:ext cx="822424" cy="228600"/>
+          </a:xfrm>
+          <a:prstGeom prst="rect">
+            <a:avLst/>
+          </a:prstGeom>
+        </p:spPr>
+        <p:txBody>
+          <a:bodyPr wrap="square" lIns="0" rIns="0" tIns="0" bIns="0">
+            <a:spAutoFit/>
+          </a:bodyPr>
+          <a:lstStyle/>
+          <a:p>
+            <a:pPr algn="l"/>
+            <a:r>
+              <a:rPr sz="825" b="1" i="0" u="none">
+                <a:solidFill>
+                  <a:srgbClr val="0A0A0F"/>
+                </a:solidFill>
+                <a:latin typeface="Inter"/>
+              </a:rPr>
+              <a:t>NEW WAY</a:t>
+            </a:r>
+          </a:p>
+        </p:txBody>
+      </p:sp>
+      <p:sp>
+        <p:nvSpPr>
+          <p:cNvPr id="21" name="TextBox 20"/>
+          <p:cNvSpPr txBox="1"/>
+          <p:nvPr/>
+        </p:nvSpPr>
+        <p:spPr>
+          <a:xfrm>
+            <a:off x="6581775" y="3107978"/>
+            <a:ext cx="209550" cy="209550"/>
+          </a:xfrm>
+          <a:prstGeom prst="rect">
+            <a:avLst/>
+          </a:prstGeom>
+          <a:solidFill>
+            <a:srgbClr val="22C55E"/>
+          </a:solidFill>
+        </p:spPr>
+        <p:txBody>
+          <a:bodyPr wrap="square" lIns="0" rIns="0" tIns="0" bIns="0">
+            <a:spAutoFit/>
+          </a:bodyPr>
+          <a:lstStyle/>
+          <a:p>
+            <a:pPr algn="l"/>
+            <a:r>
+              <a:rPr sz="975" b="1" i="0" u="none">
+                <a:solidFill>
+                  <a:srgbClr val="86EFAC"/>
+                </a:solidFill>
+                <a:latin typeface="Inter"/>
+              </a:rPr>
+              <a:t>✓</a:t>
+            </a:r>
+          </a:p>
+        </p:txBody>
+      </p:sp>
+      <p:sp>
+        <p:nvSpPr>
+          <p:cNvPr id="22" name="TextBox 21"/>
+          <p:cNvSpPr txBox="1"/>
+          <p:nvPr/>
+        </p:nvSpPr>
+        <p:spPr>
+          <a:xfrm>
+            <a:off x="6924675" y="3107978"/>
+            <a:ext cx="3670548" cy="214312"/>
+          </a:xfrm>
+          <a:prstGeom prst="rect">
+            <a:avLst/>
+          </a:prstGeom>
+          <a:noFill/>
+        </p:spPr>
+        <p:txBody>
+          <a:bodyPr wrap="square" lIns="0" rIns="0" tIns="0" bIns="0">
+            <a:spAutoFit/>
+          </a:bodyPr>
+          <a:lstStyle/>
+          <a:p>
+            <a:r>
+              <a:rPr sz="1125" b="0">
+                <a:solidFill>
+                  <a:srgbClr val="E4E4E7"/>
+                </a:solidFill>
+                <a:latin typeface="Inter"/>
+              </a:rPr>
+              <a:t>• Headlines, body copy, and bullets are real text frames.</a:t>
+            </a:r>
+          </a:p>
+        </p:txBody>
+      </p:sp>
+      <p:sp>
+        <p:nvSpPr>
+          <p:cNvPr id="23" name="TextBox 22"/>
+          <p:cNvSpPr txBox="1"/>
+          <p:nvPr/>
+        </p:nvSpPr>
+        <p:spPr>
+          <a:xfrm>
+            <a:off x="6581775" y="3598515"/>
+            <a:ext cx="209550" cy="209550"/>
+          </a:xfrm>
+          <a:prstGeom prst="rect">
+            <a:avLst/>
+          </a:prstGeom>
+          <a:solidFill>
+            <a:srgbClr val="22C55E"/>
+          </a:solidFill>
+        </p:spPr>
+        <p:txBody>
+          <a:bodyPr wrap="square" lIns="0" rIns="0" tIns="0" bIns="0">
+            <a:spAutoFit/>
+          </a:bodyPr>
+          <a:lstStyle/>
+          <a:p>
+            <a:pPr algn="l"/>
+            <a:r>
+              <a:rPr sz="975" b="1" i="0" u="none">
+                <a:solidFill>
+                  <a:srgbClr val="86EFAC"/>
+                </a:solidFill>
+                <a:latin typeface="Inter"/>
+              </a:rPr>
+              <a:t>✓</a:t>
+            </a:r>
+          </a:p>
+        </p:txBody>
+      </p:sp>
+      <p:sp>
+        <p:nvSpPr>
+          <p:cNvPr id="24" name="TextBox 23"/>
+          <p:cNvSpPr txBox="1"/>
+          <p:nvPr/>
+        </p:nvSpPr>
+        <p:spPr>
+          <a:xfrm>
+            <a:off x="6924675" y="3598515"/>
+            <a:ext cx="3698825" cy="214312"/>
+          </a:xfrm>
+          <a:prstGeom prst="rect">
+            <a:avLst/>
+          </a:prstGeom>
+          <a:noFill/>
+        </p:spPr>
+        <p:txBody>
+          <a:bodyPr wrap="square" lIns="0" rIns="0" tIns="0" bIns="0">
+            <a:spAutoFit/>
+          </a:bodyPr>
+          <a:lstStyle/>
+          <a:p>
+            <a:r>
+              <a:rPr sz="1125" b="0">
+                <a:solidFill>
+                  <a:srgbClr val="E4E4E7"/>
+                </a:solidFill>
+                <a:latin typeface="Inter"/>
+              </a:rPr>
+              <a:t>• Cards, dividers, badges are native rounded rectangles.</a:t>
+            </a:r>
+          </a:p>
+        </p:txBody>
+      </p:sp>
+      <p:sp>
+        <p:nvSpPr>
+          <p:cNvPr id="25" name="TextBox 24"/>
+          <p:cNvSpPr txBox="1"/>
+          <p:nvPr/>
+        </p:nvSpPr>
+        <p:spPr>
+          <a:xfrm>
+            <a:off x="6581775" y="4089053"/>
+            <a:ext cx="209550" cy="209550"/>
+          </a:xfrm>
+          <a:prstGeom prst="rect">
+            <a:avLst/>
+          </a:prstGeom>
+          <a:solidFill>
+            <a:srgbClr val="22C55E"/>
+          </a:solidFill>
+        </p:spPr>
+        <p:txBody>
+          <a:bodyPr wrap="square" lIns="0" rIns="0" tIns="0" bIns="0">
+            <a:spAutoFit/>
+          </a:bodyPr>
+          <a:lstStyle/>
+          <a:p>
+            <a:pPr algn="l"/>
+            <a:r>
+              <a:rPr sz="975" b="1" i="0" u="none">
+                <a:solidFill>
+                  <a:srgbClr val="86EFAC"/>
+                </a:solidFill>
+                <a:latin typeface="Inter"/>
+              </a:rPr>
+              <a:t>✓</a:t>
+            </a:r>
+          </a:p>
+        </p:txBody>
+      </p:sp>
+      <p:sp>
+        <p:nvSpPr>
+          <p:cNvPr id="26" name="TextBox 25"/>
+          <p:cNvSpPr txBox="1"/>
+          <p:nvPr/>
+        </p:nvSpPr>
+        <p:spPr>
+          <a:xfrm>
+            <a:off x="6924675" y="4089053"/>
+            <a:ext cx="4137868" cy="214312"/>
+          </a:xfrm>
+          <a:prstGeom prst="rect">
+            <a:avLst/>
+          </a:prstGeom>
+          <a:noFill/>
+        </p:spPr>
+        <p:txBody>
+          <a:bodyPr wrap="square" lIns="0" rIns="0" tIns="0" bIns="0">
+            <a:spAutoFit/>
+          </a:bodyPr>
+          <a:lstStyle/>
+          <a:p>
+            <a:r>
+              <a:rPr sz="1125" b="0">
+                <a:solidFill>
+                  <a:srgbClr val="E4E4E7"/>
+                </a:solidFill>
+                <a:latin typeface="Inter"/>
+              </a:rPr>
+              <a:t>• Designers edit fonts, colors, alignment in PowerPoint directly.</a:t>
+            </a:r>
+          </a:p>
+        </p:txBody>
+      </p:sp>
+      <p:sp>
+        <p:nvSpPr>
+          <p:cNvPr id="27" name="TextBox 26"/>
+          <p:cNvSpPr txBox="1"/>
+          <p:nvPr/>
+        </p:nvSpPr>
+        <p:spPr>
+          <a:xfrm>
+            <a:off x="6581775" y="4579590"/>
+            <a:ext cx="209550" cy="209550"/>
+          </a:xfrm>
+          <a:prstGeom prst="rect">
+            <a:avLst/>
+          </a:prstGeom>
+          <a:solidFill>
+            <a:srgbClr val="22C55E"/>
+          </a:solidFill>
+        </p:spPr>
+        <p:txBody>
+          <a:bodyPr wrap="square" lIns="0" rIns="0" tIns="0" bIns="0">
+            <a:spAutoFit/>
+          </a:bodyPr>
+          <a:lstStyle/>
+          <a:p>
+            <a:pPr algn="l"/>
+            <a:r>
+              <a:rPr sz="975" b="1" i="0" u="none">
+                <a:solidFill>
+                  <a:srgbClr val="86EFAC"/>
+                </a:solidFill>
+                <a:latin typeface="Inter"/>
+              </a:rPr>
+              <a:t>✓</a:t>
+            </a:r>
+          </a:p>
+        </p:txBody>
+      </p:sp>
+      <p:sp>
+        <p:nvSpPr>
+          <p:cNvPr id="28" name="TextBox 27"/>
+          <p:cNvSpPr txBox="1"/>
+          <p:nvPr/>
+        </p:nvSpPr>
+        <p:spPr>
+          <a:xfrm>
+            <a:off x="6924675" y="4579590"/>
+            <a:ext cx="3611761" cy="214312"/>
+          </a:xfrm>
+          <a:prstGeom prst="rect">
+            <a:avLst/>
+          </a:prstGeom>
+          <a:noFill/>
+        </p:spPr>
+        <p:txBody>
+          <a:bodyPr wrap="square" lIns="0" rIns="0" tIns="0" bIns="0">
+            <a:spAutoFit/>
+          </a:bodyPr>
+          <a:lstStyle/>
+          <a:p>
+            <a:pPr algn="l"/>
+            <a:r>
+              <a:rPr sz="1125" b="0" i="0" u="none">
+                <a:solidFill>
+                  <a:srgbClr val="E4E4E7"/>
+                </a:solidFill>
+                <a:latin typeface="Inter"/>
+              </a:rPr>
+              <a:t>Only complex visuals (Chart.js, blur effects) rasterize.</a:t>
+            </a:r>
+          </a:p>
+        </p:txBody>
+      </p:sp>
+      <p:sp>
+        <p:nvSpPr>
+          <p:cNvPr id="29" name="TextBox 28"/>
+          <p:cNvSpPr txBox="1"/>
+          <p:nvPr/>
+        </p:nvSpPr>
+        <p:spPr>
+          <a:xfrm>
+            <a:off x="6581775" y="5070128"/>
+            <a:ext cx="209550" cy="209550"/>
+          </a:xfrm>
+          <a:prstGeom prst="rect">
+            <a:avLst/>
+          </a:prstGeom>
+          <a:solidFill>
+            <a:srgbClr val="22C55E"/>
+          </a:solidFill>
+        </p:spPr>
+        <p:txBody>
+          <a:bodyPr wrap="square" lIns="0" rIns="0" tIns="0" bIns="0">
+            <a:spAutoFit/>
+          </a:bodyPr>
+          <a:lstStyle/>
+          <a:p>
+            <a:pPr algn="l"/>
+            <a:r>
+              <a:rPr sz="975" b="1" i="0" u="none">
+                <a:solidFill>
+                  <a:srgbClr val="86EFAC"/>
+                </a:solidFill>
+                <a:latin typeface="Inter"/>
+              </a:rPr>
+              <a:t>✓</a:t>
+            </a:r>
+          </a:p>
+        </p:txBody>
+      </p:sp>
+      <p:sp>
+        <p:nvSpPr>
+          <p:cNvPr id="30" name="TextBox 29"/>
+          <p:cNvSpPr txBox="1"/>
+          <p:nvPr/>
+        </p:nvSpPr>
+        <p:spPr>
+          <a:xfrm>
+            <a:off x="6924675" y="5070128"/>
+            <a:ext cx="4152900" cy="428625"/>
+          </a:xfrm>
+          <a:prstGeom prst="rect">
+            <a:avLst/>
+          </a:prstGeom>
+          <a:noFill/>
+        </p:spPr>
+        <p:txBody>
+          <a:bodyPr wrap="square" lIns="0" rIns="0" tIns="0" bIns="0">
+            <a:spAutoFit/>
+          </a:bodyPr>
+          <a:lstStyle/>
+          <a:p>
+            <a:pPr algn="l"/>
+            <a:r>
+              <a:rPr sz="1125" b="0" i="0" u="none">
+                <a:solidFill>
+                  <a:srgbClr val="E4E4E7"/>
+                </a:solidFill>
+                <a:latin typeface="Inter"/>
+              </a:rPr>
+              <a:t>Output is 4 MB instead of 50 MB. Email-friendly out of the box.</a:t>
+            </a:r>
+          </a:p>
+        </p:txBody>
+      </p:sp>
+      <p:sp>
+        <p:nvSpPr>
+          <p:cNvPr id="31" name="TextBox 30"/>
+          <p:cNvSpPr txBox="1"/>
+          <p:nvPr/>
+        </p:nvSpPr>
+        <p:spPr>
+          <a:xfrm>
+            <a:off x="762000" y="6400800"/>
+            <a:ext cx="1411635" cy="152400"/>
+          </a:xfrm>
+          <a:prstGeom prst="rect">
+            <a:avLst/>
+          </a:prstGeom>
+          <a:noFill/>
+        </p:spPr>
+        <p:txBody>
+          <a:bodyPr wrap="square" lIns="0" rIns="0" tIns="0" bIns="0">
+            <a:spAutoFit/>
+          </a:bodyPr>
+          <a:lstStyle/>
+          <a:p>
+            <a:pPr algn="l"/>
+            <a:r>
+              <a:rPr sz="975" b="1" i="0" u="none">
+                <a:solidFill>
+                  <a:srgbClr val="52525B"/>
+                </a:solidFill>
+                <a:latin typeface="Inter"/>
+              </a:rPr>
+              <a:t>PIXELPITCH LABS</a:t>
+            </a:r>
+          </a:p>
+        </p:txBody>
+      </p:sp>
+      <p:sp>
+        <p:nvSpPr>
+          <p:cNvPr id="32" name="TextBox 31"/>
+          <p:cNvSpPr txBox="1"/>
+          <p:nvPr/>
+        </p:nvSpPr>
+        <p:spPr>
+          <a:xfrm>
+            <a:off x="10874127" y="6400800"/>
+            <a:ext cx="555873" cy="152400"/>
+          </a:xfrm>
+          <a:prstGeom prst="rect">
+            <a:avLst/>
+          </a:prstGeom>
+          <a:noFill/>
+        </p:spPr>
+        <p:txBody>
+          <a:bodyPr wrap="square" lIns="0" rIns="0" tIns="0" bIns="0">
+            <a:spAutoFit/>
+          </a:bodyPr>
+          <a:lstStyle/>
+          <a:p>
+            <a:pPr algn="l"/>
+            <a:r>
+              <a:rPr sz="975" b="1" i="0" u="none">
+                <a:solidFill>
+                  <a:srgbClr val="52525B"/>
+                </a:solidFill>
+                <a:latin typeface="Inter"/>
+              </a:rPr>
+              <a:t>06 / 12</a:t>
             </a:r>
           </a:p>
         </p:txBody>

</xml_diff>